<commit_message>
feat: initialize project structure with core components, documentation, data seeds, and build automation tools
</commit_message>
<xml_diff>
--- a/deliverables/VYTAL_House_Master_Deck.pptx
+++ b/deliverables/VYTAL_House_Master_Deck.pptx
@@ -2,22 +2,22 @@
 <file path=ppt/presentation.xml><?xml version="1.0" encoding="utf-8"?>
 <p:presentation xmlns:p="http://schemas.openxmlformats.org/presentationml/2006/main">
   <p:sldMasterIdLst>
-    <p:sldMasterId xmlns:r="http://schemas.openxmlformats.org/officeDocument/2006/relationships" id="2147483648" r:id="R028a1413f0594a6b"/>
+    <p:sldMasterId xmlns:r="http://schemas.openxmlformats.org/officeDocument/2006/relationships" id="2147483648" r:id="Re0de730425d443fe"/>
   </p:sldMasterIdLst>
   <p:notesMasterIdLst>
-    <p:notesMasterId xmlns:r="http://schemas.openxmlformats.org/officeDocument/2006/relationships" r:id="Rf8f455c7b0794e2b"/>
+    <p:notesMasterId xmlns:r="http://schemas.openxmlformats.org/officeDocument/2006/relationships" r:id="Re4b91a9957954969"/>
   </p:notesMasterIdLst>
   <p:sldIdLst>
-    <p:sldId xmlns:r="http://schemas.openxmlformats.org/officeDocument/2006/relationships" id="256" r:id="R41fe7c482f8547ad"/>
-    <p:sldId xmlns:r="http://schemas.openxmlformats.org/officeDocument/2006/relationships" id="257" r:id="R2a6622d1cc1841b7"/>
-    <p:sldId xmlns:r="http://schemas.openxmlformats.org/officeDocument/2006/relationships" id="258" r:id="R2449b5ea744e4ba0"/>
-    <p:sldId xmlns:r="http://schemas.openxmlformats.org/officeDocument/2006/relationships" id="259" r:id="R59a4c029a6a941b1"/>
-    <p:sldId xmlns:r="http://schemas.openxmlformats.org/officeDocument/2006/relationships" id="260" r:id="R19b77ab4aaba4898"/>
-    <p:sldId xmlns:r="http://schemas.openxmlformats.org/officeDocument/2006/relationships" id="261" r:id="R7429a08bac474fab"/>
-    <p:sldId xmlns:r="http://schemas.openxmlformats.org/officeDocument/2006/relationships" id="262" r:id="Ra25786f56ab24988"/>
-    <p:sldId xmlns:r="http://schemas.openxmlformats.org/officeDocument/2006/relationships" id="263" r:id="R329fc8e39dea4513"/>
-    <p:sldId xmlns:r="http://schemas.openxmlformats.org/officeDocument/2006/relationships" id="264" r:id="Rd636c1fe81e5440e"/>
-    <p:sldId xmlns:r="http://schemas.openxmlformats.org/officeDocument/2006/relationships" id="265" r:id="Rd246cd79bd664293"/>
+    <p:sldId xmlns:r="http://schemas.openxmlformats.org/officeDocument/2006/relationships" id="256" r:id="Ra740ccb4c7b9488a"/>
+    <p:sldId xmlns:r="http://schemas.openxmlformats.org/officeDocument/2006/relationships" id="257" r:id="R5ecb3d0c87124b2a"/>
+    <p:sldId xmlns:r="http://schemas.openxmlformats.org/officeDocument/2006/relationships" id="258" r:id="Rac2fcd5252104100"/>
+    <p:sldId xmlns:r="http://schemas.openxmlformats.org/officeDocument/2006/relationships" id="259" r:id="Rd4559a43015f4bcc"/>
+    <p:sldId xmlns:r="http://schemas.openxmlformats.org/officeDocument/2006/relationships" id="260" r:id="Ra06cb1e4a15a4b70"/>
+    <p:sldId xmlns:r="http://schemas.openxmlformats.org/officeDocument/2006/relationships" id="261" r:id="R4532f6b717a84e18"/>
+    <p:sldId xmlns:r="http://schemas.openxmlformats.org/officeDocument/2006/relationships" id="262" r:id="Rf5a816cbb96149d0"/>
+    <p:sldId xmlns:r="http://schemas.openxmlformats.org/officeDocument/2006/relationships" id="263" r:id="R1c200813a3f54301"/>
+    <p:sldId xmlns:r="http://schemas.openxmlformats.org/officeDocument/2006/relationships" id="264" r:id="Rea673501b2ae4113"/>
+    <p:sldId xmlns:r="http://schemas.openxmlformats.org/officeDocument/2006/relationships" id="265" r:id="R21d0437ae78e494d"/>
   </p:sldIdLst>
   <p:sldSz cx="12192000" cy="6858000"/>
   <p:notesSz cx="6858000" cy="9144000"/>
@@ -1204,7 +1204,7 @@
   </p:cSld>
   <p:clrMap bg1="lt1" tx1="dk1" bg2="lt2" tx2="dk2" accent1="accent1" accent2="accent2" accent3="accent3" accent4="accent4" accent5="accent5" accent6="accent6" hlink="hlink" folHlink="folHlink"/>
   <p:sldLayoutIdLst>
-    <p:sldLayoutId xmlns:r="http://schemas.openxmlformats.org/officeDocument/2006/relationships" id="2147483649" r:id="Rcf8182727dab4c70"/>
+    <p:sldLayoutId xmlns:r="http://schemas.openxmlformats.org/officeDocument/2006/relationships" id="2147483649" r:id="R5870b5356a604d63"/>
   </p:sldLayoutIdLst>
   <p:txStyles>
     <p:titleStyle>
@@ -1755,7 +1755,7 @@
           <p:cNvPr id="1" name="">
             <a:extLst xmlns:a="http://schemas.openxmlformats.org/drawingml/2006/main">
               <a:ext uri="{FF2B5EF4-FFF2-40B4-BE49-F238E27FC236}">
-                <a16:creationId xmlns:a16="http://schemas.microsoft.com/office/drawing/2014/main" id="{6FA9609E-C4DB-49F1-AAFF-1A9F877D3FF2}"/>
+                <a16:creationId xmlns:a16="http://schemas.microsoft.com/office/drawing/2014/main" id="{4081D3B7-B61E-4AA7-B315-CAF73A00BAB3}"/>
               </a:ext>
             </a:extLst>
           </p:cNvPr>
@@ -1811,7 +1811,7 @@
           <p:cNvPr id="2" name="">
             <a:extLst xmlns:a="http://schemas.openxmlformats.org/drawingml/2006/main">
               <a:ext uri="{FF2B5EF4-FFF2-40B4-BE49-F238E27FC236}">
-                <a16:creationId xmlns:a16="http://schemas.microsoft.com/office/drawing/2014/main" id="{E23A6D70-7539-449C-B7C3-0800ACEAC8C0}"/>
+                <a16:creationId xmlns:a16="http://schemas.microsoft.com/office/drawing/2014/main" id="{1DA8494E-4460-43FF-A19F-33C0BB2BE144}"/>
               </a:ext>
             </a:extLst>
           </p:cNvPr>
@@ -1867,7 +1867,7 @@
           <p:cNvPr id="3" name="">
             <a:extLst xmlns:a="http://schemas.openxmlformats.org/drawingml/2006/main">
               <a:ext uri="{FF2B5EF4-FFF2-40B4-BE49-F238E27FC236}">
-                <a16:creationId xmlns:a16="http://schemas.microsoft.com/office/drawing/2014/main" id="{9FB172AF-FFEE-49F5-BB9C-A694DF08DA54}"/>
+                <a16:creationId xmlns:a16="http://schemas.microsoft.com/office/drawing/2014/main" id="{56591CC1-91F6-44E9-8F4E-BF83BDE246A1}"/>
               </a:ext>
             </a:extLst>
           </p:cNvPr>
@@ -1923,7 +1923,7 @@
           <p:cNvPr id="4" name="">
             <a:extLst xmlns:a="http://schemas.openxmlformats.org/drawingml/2006/main">
               <a:ext uri="{FF2B5EF4-FFF2-40B4-BE49-F238E27FC236}">
-                <a16:creationId xmlns:a16="http://schemas.microsoft.com/office/drawing/2014/main" id="{60A82064-AD41-41E6-8D90-D7AA3514BDD2}"/>
+                <a16:creationId xmlns:a16="http://schemas.microsoft.com/office/drawing/2014/main" id="{091EDC6E-5846-4790-83EC-87B8931AD26F}"/>
               </a:ext>
             </a:extLst>
           </p:cNvPr>
@@ -1979,7 +1979,7 @@
           <p:cNvPr id="5" name="">
             <a:extLst xmlns:a="http://schemas.openxmlformats.org/drawingml/2006/main">
               <a:ext uri="{FF2B5EF4-FFF2-40B4-BE49-F238E27FC236}">
-                <a16:creationId xmlns:a16="http://schemas.microsoft.com/office/drawing/2014/main" id="{C4CEB8D6-6D3C-4335-96C9-06941F1BF700}"/>
+                <a16:creationId xmlns:a16="http://schemas.microsoft.com/office/drawing/2014/main" id="{95CD6C84-4B3A-477E-9343-083135EE1AC8}"/>
               </a:ext>
             </a:extLst>
           </p:cNvPr>
@@ -2014,7 +2014,7 @@
           <p:cNvPr id="6" name="">
             <a:extLst xmlns:a="http://schemas.openxmlformats.org/drawingml/2006/main">
               <a:ext uri="{FF2B5EF4-FFF2-40B4-BE49-F238E27FC236}">
-                <a16:creationId xmlns:a16="http://schemas.microsoft.com/office/drawing/2014/main" id="{2EC0523E-1909-422B-9BB7-94DC947C48B9}"/>
+                <a16:creationId xmlns:a16="http://schemas.microsoft.com/office/drawing/2014/main" id="{80B66235-5B51-4751-93A4-1B229D281778}"/>
               </a:ext>
             </a:extLst>
           </p:cNvPr>
@@ -2070,7 +2070,7 @@
           <p:cNvPr id="7" name="">
             <a:extLst xmlns:a="http://schemas.openxmlformats.org/drawingml/2006/main">
               <a:ext uri="{FF2B5EF4-FFF2-40B4-BE49-F238E27FC236}">
-                <a16:creationId xmlns:a16="http://schemas.microsoft.com/office/drawing/2014/main" id="{7564E503-58D2-40B0-B4A5-E4BC99A05550}"/>
+                <a16:creationId xmlns:a16="http://schemas.microsoft.com/office/drawing/2014/main" id="{749C7A00-511D-4397-9942-86EDBB2F7F88}"/>
               </a:ext>
             </a:extLst>
           </p:cNvPr>
@@ -2126,7 +2126,7 @@
           <p:cNvPr id="8" name="">
             <a:extLst xmlns:a="http://schemas.openxmlformats.org/drawingml/2006/main">
               <a:ext uri="{FF2B5EF4-FFF2-40B4-BE49-F238E27FC236}">
-                <a16:creationId xmlns:a16="http://schemas.microsoft.com/office/drawing/2014/main" id="{43D5D6A1-FE33-4CC4-9806-832EACAFCFF5}"/>
+                <a16:creationId xmlns:a16="http://schemas.microsoft.com/office/drawing/2014/main" id="{A08E6BBA-CFB9-480E-B19A-6F1A344BE555}"/>
               </a:ext>
             </a:extLst>
           </p:cNvPr>
@@ -2182,7 +2182,7 @@
           <p:cNvPr id="9" name="">
             <a:extLst xmlns:a="http://schemas.openxmlformats.org/drawingml/2006/main">
               <a:ext uri="{FF2B5EF4-FFF2-40B4-BE49-F238E27FC236}">
-                <a16:creationId xmlns:a16="http://schemas.microsoft.com/office/drawing/2014/main" id="{05BD0960-8076-4633-BBFD-B9C2D8AFAE5D}"/>
+                <a16:creationId xmlns:a16="http://schemas.microsoft.com/office/drawing/2014/main" id="{646199EC-2948-4607-9FB6-8F7FD4C19D4F}"/>
               </a:ext>
             </a:extLst>
           </p:cNvPr>
@@ -2238,7 +2238,7 @@
           <p:cNvPr id="10" name="">
             <a:extLst xmlns:a="http://schemas.openxmlformats.org/drawingml/2006/main">
               <a:ext uri="{FF2B5EF4-FFF2-40B4-BE49-F238E27FC236}">
-                <a16:creationId xmlns:a16="http://schemas.microsoft.com/office/drawing/2014/main" id="{C0786260-39B8-4528-B862-20C3A9F72FC6}"/>
+                <a16:creationId xmlns:a16="http://schemas.microsoft.com/office/drawing/2014/main" id="{7721BBEA-B1C4-47CC-91F6-7DA9B0CA9516}"/>
               </a:ext>
             </a:extLst>
           </p:cNvPr>
@@ -2271,7 +2271,7 @@
           <p:cNvPr id="11" name="">
             <a:extLst xmlns:a="http://schemas.openxmlformats.org/drawingml/2006/main">
               <a:ext uri="{FF2B5EF4-FFF2-40B4-BE49-F238E27FC236}">
-                <a16:creationId xmlns:a16="http://schemas.microsoft.com/office/drawing/2014/main" id="{BBC66CF9-379E-499E-B167-64197F0D7BEB}"/>
+                <a16:creationId xmlns:a16="http://schemas.microsoft.com/office/drawing/2014/main" id="{41B54934-E8CF-4054-AB51-4B0A2A36CF1A}"/>
               </a:ext>
             </a:extLst>
           </p:cNvPr>
@@ -2317,7 +2317,7 @@
                 <a:ea typeface="Aptos"/>
                 <a:cs typeface="Aptos"/>
               </a:rPr>
-              <a:t>Owned by Chauncey Gardner and Kathy Ha.</a:t>
+              <a:t>Target site: 6000 Merriweather Drive, Columbia, MD 21044.</a:t>
             </a:r>
           </a:p>
         </p:txBody>
@@ -2327,7 +2327,7 @@
           <p:cNvPr id="12" name="">
             <a:extLst xmlns:a="http://schemas.openxmlformats.org/drawingml/2006/main">
               <a:ext uri="{FF2B5EF4-FFF2-40B4-BE49-F238E27FC236}">
-                <a16:creationId xmlns:a16="http://schemas.microsoft.com/office/drawing/2014/main" id="{1EEBA171-78CD-4C8D-A846-F44DBB8E9D9A}"/>
+                <a16:creationId xmlns:a16="http://schemas.microsoft.com/office/drawing/2014/main" id="{7354F23A-6753-461B-A860-2CC2CDAD0D5A}"/>
               </a:ext>
             </a:extLst>
           </p:cNvPr>
@@ -2360,7 +2360,7 @@
           <p:cNvPr id="13" name="">
             <a:extLst xmlns:a="http://schemas.openxmlformats.org/drawingml/2006/main">
               <a:ext uri="{FF2B5EF4-FFF2-40B4-BE49-F238E27FC236}">
-                <a16:creationId xmlns:a16="http://schemas.microsoft.com/office/drawing/2014/main" id="{4EEE9A64-5EAD-4A88-8B1D-78220F32004E}"/>
+                <a16:creationId xmlns:a16="http://schemas.microsoft.com/office/drawing/2014/main" id="{61E61419-90B1-46F2-8515-B4DC729BE495}"/>
               </a:ext>
             </a:extLst>
           </p:cNvPr>
@@ -2406,7 +2406,7 @@
                 <a:ea typeface="Aptos"/>
                 <a:cs typeface="Aptos"/>
               </a:rPr>
-              <a:t>Local draft package with external actions gated.</a:t>
+              <a:t>Owned by Chauncey Gardner and Kathy Ha.</a:t>
             </a:r>
           </a:p>
         </p:txBody>
@@ -2416,7 +2416,7 @@
           <p:cNvPr id="14" name="">
             <a:extLst xmlns:a="http://schemas.openxmlformats.org/drawingml/2006/main">
               <a:ext uri="{FF2B5EF4-FFF2-40B4-BE49-F238E27FC236}">
-                <a16:creationId xmlns:a16="http://schemas.microsoft.com/office/drawing/2014/main" id="{C814304E-8F4F-4584-95F7-517097B7CCF4}"/>
+                <a16:creationId xmlns:a16="http://schemas.microsoft.com/office/drawing/2014/main" id="{50459874-F690-43EB-8D73-10811F0C30C0}"/>
               </a:ext>
             </a:extLst>
           </p:cNvPr>
@@ -2449,7 +2449,96 @@
           <p:cNvPr id="15" name="">
             <a:extLst xmlns:a="http://schemas.openxmlformats.org/drawingml/2006/main">
               <a:ext uri="{FF2B5EF4-FFF2-40B4-BE49-F238E27FC236}">
-                <a16:creationId xmlns:a16="http://schemas.microsoft.com/office/drawing/2014/main" id="{8A787D62-7C17-4266-B326-90B7C91ABD5A}"/>
+                <a16:creationId xmlns:a16="http://schemas.microsoft.com/office/drawing/2014/main" id="{156114E1-3CF2-4755-A2AB-DC2D8D3797C2}"/>
+              </a:ext>
+            </a:extLst>
+          </p:cNvPr>
+          <p:cNvSpPr>
+            <a:spLocks xmlns:a="http://schemas.openxmlformats.org/drawingml/2006/main" noGrp="1"/>
+          </p:cNvSpPr>
+          <p:nvPr/>
+        </p:nvSpPr>
+        <p:spPr>
+          <a:xfrm xmlns:a="http://schemas.openxmlformats.org/drawingml/2006/main">
+            <a:off x="838200" y="4286250"/>
+            <a:ext cx="5638800" cy="323850"/>
+          </a:xfrm>
+          <a:prstGeom xmlns:a="http://schemas.openxmlformats.org/drawingml/2006/main" prst="rect">
+            <a:avLst/>
+          </a:prstGeom>
+          <a:noFill xmlns:a="http://schemas.openxmlformats.org/drawingml/2006/main"/>
+          <a:ln xmlns:a="http://schemas.openxmlformats.org/drawingml/2006/main" w="0">
+            <a:noFill/>
+            <a:prstDash val="solid"/>
+          </a:ln>
+        </p:spPr>
+        <p:txBody>
+          <a:bodyPr xmlns:a="http://schemas.openxmlformats.org/drawingml/2006/main"/>
+          <a:lstStyle xmlns:a="http://schemas.openxmlformats.org/drawingml/2006/main"/>
+          <a:p xmlns:a="http://schemas.openxmlformats.org/drawingml/2006/main">
+            <a:pPr>
+              <a:defRPr sz="1425">
+                <a:solidFill>
+                  <a:srgbClr val="F6F0E6"/>
+                </a:solidFill>
+                <a:latin typeface="Aptos"/>
+                <a:ea typeface="Aptos"/>
+                <a:cs typeface="Aptos"/>
+              </a:defRPr>
+            </a:pPr>
+            <a:r>
+              <a:rPr sz="1425">
+                <a:solidFill>
+                  <a:srgbClr val="F6F0E6"/>
+                </a:solidFill>
+                <a:latin typeface="Aptos"/>
+                <a:ea typeface="Aptos"/>
+                <a:cs typeface="Aptos"/>
+              </a:rPr>
+              <a:t>Local draft package with external actions gated.</a:t>
+            </a:r>
+          </a:p>
+        </p:txBody>
+      </p:sp>
+      <p:sp>
+        <p:nvSpPr>
+          <p:cNvPr id="16" name="">
+            <a:extLst xmlns:a="http://schemas.openxmlformats.org/drawingml/2006/main">
+              <a:ext uri="{FF2B5EF4-FFF2-40B4-BE49-F238E27FC236}">
+                <a16:creationId xmlns:a16="http://schemas.microsoft.com/office/drawing/2014/main" id="{0F3F6A09-0F16-44FA-B821-3881D11891BB}"/>
+              </a:ext>
+            </a:extLst>
+          </p:cNvPr>
+          <p:cNvSpPr>
+            <a:spLocks xmlns:a="http://schemas.openxmlformats.org/drawingml/2006/main" noGrp="1"/>
+          </p:cNvSpPr>
+          <p:nvPr/>
+        </p:nvSpPr>
+        <p:spPr>
+          <a:xfrm xmlns:a="http://schemas.openxmlformats.org/drawingml/2006/main">
+            <a:off x="628650" y="4362450"/>
+            <a:ext cx="76200" cy="76200"/>
+          </a:xfrm>
+          <a:prstGeom xmlns:a="http://schemas.openxmlformats.org/drawingml/2006/main" prst="ellipse">
+            <a:avLst/>
+          </a:prstGeom>
+          <a:solidFill xmlns:a="http://schemas.openxmlformats.org/drawingml/2006/main">
+            <a:srgbClr val="C8A46B"/>
+          </a:solidFill>
+          <a:ln xmlns:a="http://schemas.openxmlformats.org/drawingml/2006/main" w="9525">
+            <a:solidFill>
+              <a:srgbClr val="C8A46B"/>
+            </a:solidFill>
+            <a:prstDash val="solid"/>
+          </a:ln>
+        </p:spPr>
+      </p:sp>
+      <p:sp>
+        <p:nvSpPr>
+          <p:cNvPr id="17" name="">
+            <a:extLst xmlns:a="http://schemas.openxmlformats.org/drawingml/2006/main">
+              <a:ext uri="{FF2B5EF4-FFF2-40B4-BE49-F238E27FC236}">
+                <a16:creationId xmlns:a16="http://schemas.microsoft.com/office/drawing/2014/main" id="{7511AC3B-CFE2-43D4-9598-9AD86BC80788}"/>
               </a:ext>
             </a:extLst>
           </p:cNvPr>
@@ -2503,7 +2592,7 @@
     </p:spTree>
     <p:extLst>
       <p:ext uri="{BB962C8B-B14F-4D97-AF65-F5344CB8AC3E}">
-        <p14:creationId xmlns:p14="http://schemas.microsoft.com/office/powerpoint/2010/main" val="1896808995"/>
+        <p14:creationId xmlns:p14="http://schemas.microsoft.com/office/powerpoint/2010/main" val="1519504400"/>
       </p:ext>
     </p:extLst>
   </p:cSld>
@@ -2534,7 +2623,7 @@
           <p:cNvPr id="1" name="">
             <a:extLst xmlns:a="http://schemas.openxmlformats.org/drawingml/2006/main">
               <a:ext uri="{FF2B5EF4-FFF2-40B4-BE49-F238E27FC236}">
-                <a16:creationId xmlns:a16="http://schemas.microsoft.com/office/drawing/2014/main" id="{089EA735-D59E-4239-8F59-165FCE353E8C}"/>
+                <a16:creationId xmlns:a16="http://schemas.microsoft.com/office/drawing/2014/main" id="{A09E7DCB-D513-4AD0-A479-27D0B602C8A7}"/>
               </a:ext>
             </a:extLst>
           </p:cNvPr>
@@ -2590,7 +2679,7 @@
           <p:cNvPr id="2" name="">
             <a:extLst xmlns:a="http://schemas.openxmlformats.org/drawingml/2006/main">
               <a:ext uri="{FF2B5EF4-FFF2-40B4-BE49-F238E27FC236}">
-                <a16:creationId xmlns:a16="http://schemas.microsoft.com/office/drawing/2014/main" id="{AE0ED8C5-A79A-44EE-BC08-128C04751E91}"/>
+                <a16:creationId xmlns:a16="http://schemas.microsoft.com/office/drawing/2014/main" id="{509763E1-6ED5-408F-88FF-085017D184AE}"/>
               </a:ext>
             </a:extLst>
           </p:cNvPr>
@@ -2646,7 +2735,7 @@
           <p:cNvPr id="3" name="">
             <a:extLst xmlns:a="http://schemas.openxmlformats.org/drawingml/2006/main">
               <a:ext uri="{FF2B5EF4-FFF2-40B4-BE49-F238E27FC236}">
-                <a16:creationId xmlns:a16="http://schemas.microsoft.com/office/drawing/2014/main" id="{771B6CBB-34F3-4F81-8999-6B2C28202C01}"/>
+                <a16:creationId xmlns:a16="http://schemas.microsoft.com/office/drawing/2014/main" id="{3D957E16-499A-442D-AAB9-D618018198A4}"/>
               </a:ext>
             </a:extLst>
           </p:cNvPr>
@@ -2702,7 +2791,7 @@
           <p:cNvPr id="4" name="">
             <a:extLst xmlns:a="http://schemas.openxmlformats.org/drawingml/2006/main">
               <a:ext uri="{FF2B5EF4-FFF2-40B4-BE49-F238E27FC236}">
-                <a16:creationId xmlns:a16="http://schemas.microsoft.com/office/drawing/2014/main" id="{E0670569-6FD2-4916-887C-992BB3501DB3}"/>
+                <a16:creationId xmlns:a16="http://schemas.microsoft.com/office/drawing/2014/main" id="{A87C8E4C-A3E9-4ED4-BE20-EC91E909E4E5}"/>
               </a:ext>
             </a:extLst>
           </p:cNvPr>
@@ -2758,7 +2847,7 @@
           <p:cNvPr id="5" name="">
             <a:extLst xmlns:a="http://schemas.openxmlformats.org/drawingml/2006/main">
               <a:ext uri="{FF2B5EF4-FFF2-40B4-BE49-F238E27FC236}">
-                <a16:creationId xmlns:a16="http://schemas.microsoft.com/office/drawing/2014/main" id="{7103F023-F46D-40AC-8E74-B66490966E49}"/>
+                <a16:creationId xmlns:a16="http://schemas.microsoft.com/office/drawing/2014/main" id="{E4EBD9DC-0837-4AB0-B9B1-FFA8BABF0DC2}"/>
               </a:ext>
             </a:extLst>
           </p:cNvPr>
@@ -2793,7 +2882,7 @@
           <p:cNvPr id="6" name="">
             <a:extLst xmlns:a="http://schemas.openxmlformats.org/drawingml/2006/main">
               <a:ext uri="{FF2B5EF4-FFF2-40B4-BE49-F238E27FC236}">
-                <a16:creationId xmlns:a16="http://schemas.microsoft.com/office/drawing/2014/main" id="{1ADCC644-6CCC-44C8-BCBF-D7DA5C6DB4D5}"/>
+                <a16:creationId xmlns:a16="http://schemas.microsoft.com/office/drawing/2014/main" id="{378B0019-7834-4BB7-B592-BBBC13770F86}"/>
               </a:ext>
             </a:extLst>
           </p:cNvPr>
@@ -2849,7 +2938,7 @@
           <p:cNvPr id="7" name="">
             <a:extLst xmlns:a="http://schemas.openxmlformats.org/drawingml/2006/main">
               <a:ext uri="{FF2B5EF4-FFF2-40B4-BE49-F238E27FC236}">
-                <a16:creationId xmlns:a16="http://schemas.microsoft.com/office/drawing/2014/main" id="{9DF0A484-CD62-4CCC-9660-9A7835A0BDAB}"/>
+                <a16:creationId xmlns:a16="http://schemas.microsoft.com/office/drawing/2014/main" id="{A3209CE3-7527-493D-9AF4-F03D04CC0AD6}"/>
               </a:ext>
             </a:extLst>
           </p:cNvPr>
@@ -2905,7 +2994,7 @@
           <p:cNvPr id="8" name="">
             <a:extLst xmlns:a="http://schemas.openxmlformats.org/drawingml/2006/main">
               <a:ext uri="{FF2B5EF4-FFF2-40B4-BE49-F238E27FC236}">
-                <a16:creationId xmlns:a16="http://schemas.microsoft.com/office/drawing/2014/main" id="{FFA0DC90-9473-45A5-89C9-3C71DE8B9A86}"/>
+                <a16:creationId xmlns:a16="http://schemas.microsoft.com/office/drawing/2014/main" id="{22386246-E3E4-4B7E-8C3B-0266A6ADDCDD}"/>
               </a:ext>
             </a:extLst>
           </p:cNvPr>
@@ -2961,7 +3050,7 @@
           <p:cNvPr id="9" name="">
             <a:extLst xmlns:a="http://schemas.openxmlformats.org/drawingml/2006/main">
               <a:ext uri="{FF2B5EF4-FFF2-40B4-BE49-F238E27FC236}">
-                <a16:creationId xmlns:a16="http://schemas.microsoft.com/office/drawing/2014/main" id="{20F91BC1-E2A8-47D9-8811-63F8E4CA0265}"/>
+                <a16:creationId xmlns:a16="http://schemas.microsoft.com/office/drawing/2014/main" id="{D2A20CDF-5D3B-43A5-ABA7-8B416A87C85B}"/>
               </a:ext>
             </a:extLst>
           </p:cNvPr>
@@ -3017,7 +3106,7 @@
           <p:cNvPr id="10" name="">
             <a:extLst xmlns:a="http://schemas.openxmlformats.org/drawingml/2006/main">
               <a:ext uri="{FF2B5EF4-FFF2-40B4-BE49-F238E27FC236}">
-                <a16:creationId xmlns:a16="http://schemas.microsoft.com/office/drawing/2014/main" id="{F6038FCA-3F29-492B-B787-3C9D92F790E3}"/>
+                <a16:creationId xmlns:a16="http://schemas.microsoft.com/office/drawing/2014/main" id="{F27A8D89-4ADD-4819-A478-CB8218D48DF0}"/>
               </a:ext>
             </a:extLst>
           </p:cNvPr>
@@ -3050,7 +3139,7 @@
           <p:cNvPr id="11" name="">
             <a:extLst xmlns:a="http://schemas.openxmlformats.org/drawingml/2006/main">
               <a:ext uri="{FF2B5EF4-FFF2-40B4-BE49-F238E27FC236}">
-                <a16:creationId xmlns:a16="http://schemas.microsoft.com/office/drawing/2014/main" id="{E593BAE4-B166-4D85-A535-67E2BDAB784B}"/>
+                <a16:creationId xmlns:a16="http://schemas.microsoft.com/office/drawing/2014/main" id="{3D4204D5-CA97-4A73-BE00-19F1EDBEF28F}"/>
               </a:ext>
             </a:extLst>
           </p:cNvPr>
@@ -3106,7 +3195,7 @@
           <p:cNvPr id="12" name="">
             <a:extLst xmlns:a="http://schemas.openxmlformats.org/drawingml/2006/main">
               <a:ext uri="{FF2B5EF4-FFF2-40B4-BE49-F238E27FC236}">
-                <a16:creationId xmlns:a16="http://schemas.microsoft.com/office/drawing/2014/main" id="{E213A082-639F-4DF3-B86D-32CAFBC66918}"/>
+                <a16:creationId xmlns:a16="http://schemas.microsoft.com/office/drawing/2014/main" id="{0DF6B871-C453-4057-861F-8FD5774E1329}"/>
               </a:ext>
             </a:extLst>
           </p:cNvPr>
@@ -3139,7 +3228,7 @@
           <p:cNvPr id="13" name="">
             <a:extLst xmlns:a="http://schemas.openxmlformats.org/drawingml/2006/main">
               <a:ext uri="{FF2B5EF4-FFF2-40B4-BE49-F238E27FC236}">
-                <a16:creationId xmlns:a16="http://schemas.microsoft.com/office/drawing/2014/main" id="{4EA182CF-7E97-4622-BC02-09A38259E17E}"/>
+                <a16:creationId xmlns:a16="http://schemas.microsoft.com/office/drawing/2014/main" id="{B6DCB1E6-EDBA-4789-A158-4EE7815F8B66}"/>
               </a:ext>
             </a:extLst>
           </p:cNvPr>
@@ -3185,7 +3274,7 @@
                 <a:ea typeface="Aptos"/>
                 <a:cs typeface="Aptos"/>
               </a:rPr>
-              <a:t>Approve Notion/Figma live creation only when ready.</a:t>
+              <a:t>Approve Firebase, Google Cloud, Notion, and Figma live creation only when ready.</a:t>
             </a:r>
           </a:p>
         </p:txBody>
@@ -3195,7 +3284,7 @@
           <p:cNvPr id="14" name="">
             <a:extLst xmlns:a="http://schemas.openxmlformats.org/drawingml/2006/main">
               <a:ext uri="{FF2B5EF4-FFF2-40B4-BE49-F238E27FC236}">
-                <a16:creationId xmlns:a16="http://schemas.microsoft.com/office/drawing/2014/main" id="{28C219DA-CF4B-4B43-8165-07D5B4CDCB89}"/>
+                <a16:creationId xmlns:a16="http://schemas.microsoft.com/office/drawing/2014/main" id="{B9C18B77-1141-4EF1-BE49-7A7AD6B401D7}"/>
               </a:ext>
             </a:extLst>
           </p:cNvPr>
@@ -3228,7 +3317,7 @@
           <p:cNvPr id="15" name="">
             <a:extLst xmlns:a="http://schemas.openxmlformats.org/drawingml/2006/main">
               <a:ext uri="{FF2B5EF4-FFF2-40B4-BE49-F238E27FC236}">
-                <a16:creationId xmlns:a16="http://schemas.microsoft.com/office/drawing/2014/main" id="{55C49DC3-2C80-4348-AA47-1487D11C4452}"/>
+                <a16:creationId xmlns:a16="http://schemas.microsoft.com/office/drawing/2014/main" id="{8AF2D065-2250-4F9A-8DE7-3BD78933A9B0}"/>
               </a:ext>
             </a:extLst>
           </p:cNvPr>
@@ -3282,7 +3371,7 @@
     </p:spTree>
     <p:extLst>
       <p:ext uri="{BB962C8B-B14F-4D97-AF65-F5344CB8AC3E}">
-        <p14:creationId xmlns:p14="http://schemas.microsoft.com/office/powerpoint/2010/main" val="1209688528"/>
+        <p14:creationId xmlns:p14="http://schemas.microsoft.com/office/powerpoint/2010/main" val="863337167"/>
       </p:ext>
     </p:extLst>
   </p:cSld>
@@ -3313,7 +3402,7 @@
           <p:cNvPr id="1" name="">
             <a:extLst xmlns:a="http://schemas.openxmlformats.org/drawingml/2006/main">
               <a:ext uri="{FF2B5EF4-FFF2-40B4-BE49-F238E27FC236}">
-                <a16:creationId xmlns:a16="http://schemas.microsoft.com/office/drawing/2014/main" id="{D7F0C6D7-5D73-447E-9820-EB21E91F0CC2}"/>
+                <a16:creationId xmlns:a16="http://schemas.microsoft.com/office/drawing/2014/main" id="{96CB83F2-FA3B-4D46-A42F-DA5CB19F3239}"/>
               </a:ext>
             </a:extLst>
           </p:cNvPr>
@@ -3369,7 +3458,7 @@
           <p:cNvPr id="2" name="">
             <a:extLst xmlns:a="http://schemas.openxmlformats.org/drawingml/2006/main">
               <a:ext uri="{FF2B5EF4-FFF2-40B4-BE49-F238E27FC236}">
-                <a16:creationId xmlns:a16="http://schemas.microsoft.com/office/drawing/2014/main" id="{655CA00F-0EDD-4DC2-9DBC-331904371B81}"/>
+                <a16:creationId xmlns:a16="http://schemas.microsoft.com/office/drawing/2014/main" id="{AA7D756B-0C47-4649-9B18-E094DD39CB0F}"/>
               </a:ext>
             </a:extLst>
           </p:cNvPr>
@@ -3425,7 +3514,7 @@
           <p:cNvPr id="3" name="">
             <a:extLst xmlns:a="http://schemas.openxmlformats.org/drawingml/2006/main">
               <a:ext uri="{FF2B5EF4-FFF2-40B4-BE49-F238E27FC236}">
-                <a16:creationId xmlns:a16="http://schemas.microsoft.com/office/drawing/2014/main" id="{5475F1BA-1907-4823-A573-C642BDA22F25}"/>
+                <a16:creationId xmlns:a16="http://schemas.microsoft.com/office/drawing/2014/main" id="{EF0A963A-C46A-481E-9361-609D9E64D7F5}"/>
               </a:ext>
             </a:extLst>
           </p:cNvPr>
@@ -3481,7 +3570,7 @@
           <p:cNvPr id="4" name="">
             <a:extLst xmlns:a="http://schemas.openxmlformats.org/drawingml/2006/main">
               <a:ext uri="{FF2B5EF4-FFF2-40B4-BE49-F238E27FC236}">
-                <a16:creationId xmlns:a16="http://schemas.microsoft.com/office/drawing/2014/main" id="{5C1408A1-4D65-4650-8DAA-09863F72C86D}"/>
+                <a16:creationId xmlns:a16="http://schemas.microsoft.com/office/drawing/2014/main" id="{F2459DF2-5D0F-4E9C-8413-FC91CB79A3EA}"/>
               </a:ext>
             </a:extLst>
           </p:cNvPr>
@@ -3537,7 +3626,7 @@
           <p:cNvPr id="5" name="">
             <a:extLst xmlns:a="http://schemas.openxmlformats.org/drawingml/2006/main">
               <a:ext uri="{FF2B5EF4-FFF2-40B4-BE49-F238E27FC236}">
-                <a16:creationId xmlns:a16="http://schemas.microsoft.com/office/drawing/2014/main" id="{B0CD628E-7AE9-4EAA-B748-EDBB5B884B26}"/>
+                <a16:creationId xmlns:a16="http://schemas.microsoft.com/office/drawing/2014/main" id="{1619AAD5-03B0-4C39-B5FB-C895D4E7E4E1}"/>
               </a:ext>
             </a:extLst>
           </p:cNvPr>
@@ -3572,7 +3661,7 @@
           <p:cNvPr id="6" name="">
             <a:extLst xmlns:a="http://schemas.openxmlformats.org/drawingml/2006/main">
               <a:ext uri="{FF2B5EF4-FFF2-40B4-BE49-F238E27FC236}">
-                <a16:creationId xmlns:a16="http://schemas.microsoft.com/office/drawing/2014/main" id="{CA38FB94-A1EC-4B5E-8AFC-2ABD4EFE06C9}"/>
+                <a16:creationId xmlns:a16="http://schemas.microsoft.com/office/drawing/2014/main" id="{ED6327D0-34C8-4849-A031-4F3C916B4DB4}"/>
               </a:ext>
             </a:extLst>
           </p:cNvPr>
@@ -3628,7 +3717,7 @@
           <p:cNvPr id="7" name="">
             <a:extLst xmlns:a="http://schemas.openxmlformats.org/drawingml/2006/main">
               <a:ext uri="{FF2B5EF4-FFF2-40B4-BE49-F238E27FC236}">
-                <a16:creationId xmlns:a16="http://schemas.microsoft.com/office/drawing/2014/main" id="{FC99E829-75C4-4676-A2EF-8905A3DE7971}"/>
+                <a16:creationId xmlns:a16="http://schemas.microsoft.com/office/drawing/2014/main" id="{1B7653DE-1C66-4470-AF95-0B5B942468EF}"/>
               </a:ext>
             </a:extLst>
           </p:cNvPr>
@@ -3684,7 +3773,7 @@
           <p:cNvPr id="8" name="">
             <a:extLst xmlns:a="http://schemas.openxmlformats.org/drawingml/2006/main">
               <a:ext uri="{FF2B5EF4-FFF2-40B4-BE49-F238E27FC236}">
-                <a16:creationId xmlns:a16="http://schemas.microsoft.com/office/drawing/2014/main" id="{64D7EB77-1B4D-4076-9F4E-FD455E184B37}"/>
+                <a16:creationId xmlns:a16="http://schemas.microsoft.com/office/drawing/2014/main" id="{9C092D8D-2A78-47F2-B81B-DE7F1955FF58}"/>
               </a:ext>
             </a:extLst>
           </p:cNvPr>
@@ -3740,7 +3829,7 @@
           <p:cNvPr id="9" name="">
             <a:extLst xmlns:a="http://schemas.openxmlformats.org/drawingml/2006/main">
               <a:ext uri="{FF2B5EF4-FFF2-40B4-BE49-F238E27FC236}">
-                <a16:creationId xmlns:a16="http://schemas.microsoft.com/office/drawing/2014/main" id="{57A2682C-ACF7-47AF-BFD6-A654EE114FF0}"/>
+                <a16:creationId xmlns:a16="http://schemas.microsoft.com/office/drawing/2014/main" id="{2AA97132-B573-46B5-B5DD-7AD844623A42}"/>
               </a:ext>
             </a:extLst>
           </p:cNvPr>
@@ -3796,7 +3885,7 @@
           <p:cNvPr id="10" name="">
             <a:extLst xmlns:a="http://schemas.openxmlformats.org/drawingml/2006/main">
               <a:ext uri="{FF2B5EF4-FFF2-40B4-BE49-F238E27FC236}">
-                <a16:creationId xmlns:a16="http://schemas.microsoft.com/office/drawing/2014/main" id="{F798B0CE-5F0B-44A2-BD0E-3C0F5D9783B5}"/>
+                <a16:creationId xmlns:a16="http://schemas.microsoft.com/office/drawing/2014/main" id="{6AEAFD49-979E-4837-8888-5CCE6A720F3B}"/>
               </a:ext>
             </a:extLst>
           </p:cNvPr>
@@ -3829,7 +3918,7 @@
           <p:cNvPr id="11" name="">
             <a:extLst xmlns:a="http://schemas.openxmlformats.org/drawingml/2006/main">
               <a:ext uri="{FF2B5EF4-FFF2-40B4-BE49-F238E27FC236}">
-                <a16:creationId xmlns:a16="http://schemas.microsoft.com/office/drawing/2014/main" id="{62804F24-D20C-4751-9CE9-19F7F9E68EEF}"/>
+                <a16:creationId xmlns:a16="http://schemas.microsoft.com/office/drawing/2014/main" id="{7F796BAA-FD72-4C6D-A551-D88FC14254DC}"/>
               </a:ext>
             </a:extLst>
           </p:cNvPr>
@@ -3885,7 +3974,7 @@
           <p:cNvPr id="12" name="">
             <a:extLst xmlns:a="http://schemas.openxmlformats.org/drawingml/2006/main">
               <a:ext uri="{FF2B5EF4-FFF2-40B4-BE49-F238E27FC236}">
-                <a16:creationId xmlns:a16="http://schemas.microsoft.com/office/drawing/2014/main" id="{05B97D15-76B8-4858-82B8-34C8E48B0232}"/>
+                <a16:creationId xmlns:a16="http://schemas.microsoft.com/office/drawing/2014/main" id="{9B8B56FC-4A8A-4E95-AB6A-3D25EBF545B3}"/>
               </a:ext>
             </a:extLst>
           </p:cNvPr>
@@ -3918,7 +4007,7 @@
           <p:cNvPr id="13" name="">
             <a:extLst xmlns:a="http://schemas.openxmlformats.org/drawingml/2006/main">
               <a:ext uri="{FF2B5EF4-FFF2-40B4-BE49-F238E27FC236}">
-                <a16:creationId xmlns:a16="http://schemas.microsoft.com/office/drawing/2014/main" id="{23C0F970-2C62-4334-890A-BDA7C4CB65AA}"/>
+                <a16:creationId xmlns:a16="http://schemas.microsoft.com/office/drawing/2014/main" id="{C6603AB5-6D25-4302-A9AB-DB0CC39C6750}"/>
               </a:ext>
             </a:extLst>
           </p:cNvPr>
@@ -3974,7 +4063,7 @@
           <p:cNvPr id="14" name="">
             <a:extLst xmlns:a="http://schemas.openxmlformats.org/drawingml/2006/main">
               <a:ext uri="{FF2B5EF4-FFF2-40B4-BE49-F238E27FC236}">
-                <a16:creationId xmlns:a16="http://schemas.microsoft.com/office/drawing/2014/main" id="{DD9EE357-FCA7-4249-AADF-C34ED1A9EB89}"/>
+                <a16:creationId xmlns:a16="http://schemas.microsoft.com/office/drawing/2014/main" id="{92FBEB5F-B93A-4C43-A03C-A2D64D13C695}"/>
               </a:ext>
             </a:extLst>
           </p:cNvPr>
@@ -4007,7 +4096,7 @@
           <p:cNvPr id="15" name="">
             <a:extLst xmlns:a="http://schemas.openxmlformats.org/drawingml/2006/main">
               <a:ext uri="{FF2B5EF4-FFF2-40B4-BE49-F238E27FC236}">
-                <a16:creationId xmlns:a16="http://schemas.microsoft.com/office/drawing/2014/main" id="{D3183CE5-CA04-47F9-9DC0-21BC61F93234}"/>
+                <a16:creationId xmlns:a16="http://schemas.microsoft.com/office/drawing/2014/main" id="{2405F14B-A933-4B8E-BF95-89C3376E016E}"/>
               </a:ext>
             </a:extLst>
           </p:cNvPr>
@@ -4061,7 +4150,7 @@
     </p:spTree>
     <p:extLst>
       <p:ext uri="{BB962C8B-B14F-4D97-AF65-F5344CB8AC3E}">
-        <p14:creationId xmlns:p14="http://schemas.microsoft.com/office/powerpoint/2010/main" val="572535712"/>
+        <p14:creationId xmlns:p14="http://schemas.microsoft.com/office/powerpoint/2010/main" val="633719935"/>
       </p:ext>
     </p:extLst>
   </p:cSld>
@@ -4092,7 +4181,7 @@
           <p:cNvPr id="1" name="">
             <a:extLst xmlns:a="http://schemas.openxmlformats.org/drawingml/2006/main">
               <a:ext uri="{FF2B5EF4-FFF2-40B4-BE49-F238E27FC236}">
-                <a16:creationId xmlns:a16="http://schemas.microsoft.com/office/drawing/2014/main" id="{A494BD9C-CF8E-4E47-83A6-8AC53E3F39F3}"/>
+                <a16:creationId xmlns:a16="http://schemas.microsoft.com/office/drawing/2014/main" id="{2FFDBF84-8625-47DE-98DE-BCECAD1D1EAB}"/>
               </a:ext>
             </a:extLst>
           </p:cNvPr>
@@ -4148,7 +4237,7 @@
           <p:cNvPr id="2" name="">
             <a:extLst xmlns:a="http://schemas.openxmlformats.org/drawingml/2006/main">
               <a:ext uri="{FF2B5EF4-FFF2-40B4-BE49-F238E27FC236}">
-                <a16:creationId xmlns:a16="http://schemas.microsoft.com/office/drawing/2014/main" id="{A7C60266-FA14-4168-B70C-C8B042B517F0}"/>
+                <a16:creationId xmlns:a16="http://schemas.microsoft.com/office/drawing/2014/main" id="{47C27114-3319-448C-9F40-03372A023F4C}"/>
               </a:ext>
             </a:extLst>
           </p:cNvPr>
@@ -4204,7 +4293,7 @@
           <p:cNvPr id="3" name="">
             <a:extLst xmlns:a="http://schemas.openxmlformats.org/drawingml/2006/main">
               <a:ext uri="{FF2B5EF4-FFF2-40B4-BE49-F238E27FC236}">
-                <a16:creationId xmlns:a16="http://schemas.microsoft.com/office/drawing/2014/main" id="{811EF233-B5D9-4E6C-98CE-D1D5A9F101CB}"/>
+                <a16:creationId xmlns:a16="http://schemas.microsoft.com/office/drawing/2014/main" id="{4B684C49-BB26-4E32-B306-B355343D9951}"/>
               </a:ext>
             </a:extLst>
           </p:cNvPr>
@@ -4260,7 +4349,7 @@
           <p:cNvPr id="4" name="">
             <a:extLst xmlns:a="http://schemas.openxmlformats.org/drawingml/2006/main">
               <a:ext uri="{FF2B5EF4-FFF2-40B4-BE49-F238E27FC236}">
-                <a16:creationId xmlns:a16="http://schemas.microsoft.com/office/drawing/2014/main" id="{2B004583-115C-4706-9EF8-8CCC1B068321}"/>
+                <a16:creationId xmlns:a16="http://schemas.microsoft.com/office/drawing/2014/main" id="{80E50E84-8F43-4079-AAC9-74C40673F02F}"/>
               </a:ext>
             </a:extLst>
           </p:cNvPr>
@@ -4316,7 +4405,7 @@
           <p:cNvPr id="5" name="">
             <a:extLst xmlns:a="http://schemas.openxmlformats.org/drawingml/2006/main">
               <a:ext uri="{FF2B5EF4-FFF2-40B4-BE49-F238E27FC236}">
-                <a16:creationId xmlns:a16="http://schemas.microsoft.com/office/drawing/2014/main" id="{99F437FD-D0E8-49EB-AE2D-5ACE906311E9}"/>
+                <a16:creationId xmlns:a16="http://schemas.microsoft.com/office/drawing/2014/main" id="{EE27457B-5A7B-4D31-B0BE-7F0056FCC2BD}"/>
               </a:ext>
             </a:extLst>
           </p:cNvPr>
@@ -4351,7 +4440,7 @@
           <p:cNvPr id="6" name="">
             <a:extLst xmlns:a="http://schemas.openxmlformats.org/drawingml/2006/main">
               <a:ext uri="{FF2B5EF4-FFF2-40B4-BE49-F238E27FC236}">
-                <a16:creationId xmlns:a16="http://schemas.microsoft.com/office/drawing/2014/main" id="{41D13962-5C0E-47F0-8F6B-0EC78B2D1D30}"/>
+                <a16:creationId xmlns:a16="http://schemas.microsoft.com/office/drawing/2014/main" id="{32726537-F9F4-4EEE-A480-3FEE8F5E6CA0}"/>
               </a:ext>
             </a:extLst>
           </p:cNvPr>
@@ -4407,7 +4496,7 @@
           <p:cNvPr id="7" name="">
             <a:extLst xmlns:a="http://schemas.openxmlformats.org/drawingml/2006/main">
               <a:ext uri="{FF2B5EF4-FFF2-40B4-BE49-F238E27FC236}">
-                <a16:creationId xmlns:a16="http://schemas.microsoft.com/office/drawing/2014/main" id="{15BF4554-5367-4171-9970-9A8D0C762B95}"/>
+                <a16:creationId xmlns:a16="http://schemas.microsoft.com/office/drawing/2014/main" id="{BD55C47D-B253-4F6B-92BE-981038457321}"/>
               </a:ext>
             </a:extLst>
           </p:cNvPr>
@@ -4463,7 +4552,7 @@
           <p:cNvPr id="8" name="">
             <a:extLst xmlns:a="http://schemas.openxmlformats.org/drawingml/2006/main">
               <a:ext uri="{FF2B5EF4-FFF2-40B4-BE49-F238E27FC236}">
-                <a16:creationId xmlns:a16="http://schemas.microsoft.com/office/drawing/2014/main" id="{EA6B728B-2DEA-45ED-8373-51A7105EA0BA}"/>
+                <a16:creationId xmlns:a16="http://schemas.microsoft.com/office/drawing/2014/main" id="{F810C04D-059F-42F7-97FB-C7F3D1F3AD18}"/>
               </a:ext>
             </a:extLst>
           </p:cNvPr>
@@ -4519,7 +4608,7 @@
           <p:cNvPr id="9" name="">
             <a:extLst xmlns:a="http://schemas.openxmlformats.org/drawingml/2006/main">
               <a:ext uri="{FF2B5EF4-FFF2-40B4-BE49-F238E27FC236}">
-                <a16:creationId xmlns:a16="http://schemas.microsoft.com/office/drawing/2014/main" id="{13F1D3FC-46FC-4B09-9FBE-EEEB121FB175}"/>
+                <a16:creationId xmlns:a16="http://schemas.microsoft.com/office/drawing/2014/main" id="{BE0A4ACE-7803-4814-AD6A-EB379AB6F1D4}"/>
               </a:ext>
             </a:extLst>
           </p:cNvPr>
@@ -4575,7 +4664,7 @@
           <p:cNvPr id="10" name="">
             <a:extLst xmlns:a="http://schemas.openxmlformats.org/drawingml/2006/main">
               <a:ext uri="{FF2B5EF4-FFF2-40B4-BE49-F238E27FC236}">
-                <a16:creationId xmlns:a16="http://schemas.microsoft.com/office/drawing/2014/main" id="{DA77D27A-E641-4B19-98CB-D7A17CFD2C17}"/>
+                <a16:creationId xmlns:a16="http://schemas.microsoft.com/office/drawing/2014/main" id="{B9DC3D16-877A-4CA4-83B1-54D71D2BD31D}"/>
               </a:ext>
             </a:extLst>
           </p:cNvPr>
@@ -4608,7 +4697,7 @@
           <p:cNvPr id="11" name="">
             <a:extLst xmlns:a="http://schemas.openxmlformats.org/drawingml/2006/main">
               <a:ext uri="{FF2B5EF4-FFF2-40B4-BE49-F238E27FC236}">
-                <a16:creationId xmlns:a16="http://schemas.microsoft.com/office/drawing/2014/main" id="{5372CFB0-939E-4A22-97E3-91BA1E47CAB3}"/>
+                <a16:creationId xmlns:a16="http://schemas.microsoft.com/office/drawing/2014/main" id="{AD2F81C7-90BF-4FD3-9A36-ECFD05E0F995}"/>
               </a:ext>
             </a:extLst>
           </p:cNvPr>
@@ -4664,7 +4753,7 @@
           <p:cNvPr id="12" name="">
             <a:extLst xmlns:a="http://schemas.openxmlformats.org/drawingml/2006/main">
               <a:ext uri="{FF2B5EF4-FFF2-40B4-BE49-F238E27FC236}">
-                <a16:creationId xmlns:a16="http://schemas.microsoft.com/office/drawing/2014/main" id="{E5E2B96F-E03E-427A-9B3F-C8B3A8CEAA3C}"/>
+                <a16:creationId xmlns:a16="http://schemas.microsoft.com/office/drawing/2014/main" id="{EDCC0917-AAA5-4323-97F3-0F9201235BCD}"/>
               </a:ext>
             </a:extLst>
           </p:cNvPr>
@@ -4697,7 +4786,7 @@
           <p:cNvPr id="13" name="">
             <a:extLst xmlns:a="http://schemas.openxmlformats.org/drawingml/2006/main">
               <a:ext uri="{FF2B5EF4-FFF2-40B4-BE49-F238E27FC236}">
-                <a16:creationId xmlns:a16="http://schemas.microsoft.com/office/drawing/2014/main" id="{D385AE48-B28A-4227-A677-78BB36A55540}"/>
+                <a16:creationId xmlns:a16="http://schemas.microsoft.com/office/drawing/2014/main" id="{63048B63-3371-402D-B65E-F19361ACA653}"/>
               </a:ext>
             </a:extLst>
           </p:cNvPr>
@@ -4753,7 +4842,7 @@
           <p:cNvPr id="14" name="">
             <a:extLst xmlns:a="http://schemas.openxmlformats.org/drawingml/2006/main">
               <a:ext uri="{FF2B5EF4-FFF2-40B4-BE49-F238E27FC236}">
-                <a16:creationId xmlns:a16="http://schemas.microsoft.com/office/drawing/2014/main" id="{5783210D-6780-48AB-8172-5674ACFBCC95}"/>
+                <a16:creationId xmlns:a16="http://schemas.microsoft.com/office/drawing/2014/main" id="{A648B164-19E9-486F-B94A-68A94C510031}"/>
               </a:ext>
             </a:extLst>
           </p:cNvPr>
@@ -4786,7 +4875,7 @@
           <p:cNvPr id="15" name="">
             <a:extLst xmlns:a="http://schemas.openxmlformats.org/drawingml/2006/main">
               <a:ext uri="{FF2B5EF4-FFF2-40B4-BE49-F238E27FC236}">
-                <a16:creationId xmlns:a16="http://schemas.microsoft.com/office/drawing/2014/main" id="{7EE315BD-A712-4BE0-9714-861926C2D06A}"/>
+                <a16:creationId xmlns:a16="http://schemas.microsoft.com/office/drawing/2014/main" id="{224A4BC6-378B-48A8-86DE-124F2B03E65C}"/>
               </a:ext>
             </a:extLst>
           </p:cNvPr>
@@ -4840,7 +4929,7 @@
     </p:spTree>
     <p:extLst>
       <p:ext uri="{BB962C8B-B14F-4D97-AF65-F5344CB8AC3E}">
-        <p14:creationId xmlns:p14="http://schemas.microsoft.com/office/powerpoint/2010/main" val="808132293"/>
+        <p14:creationId xmlns:p14="http://schemas.microsoft.com/office/powerpoint/2010/main" val="691467180"/>
       </p:ext>
     </p:extLst>
   </p:cSld>
@@ -4871,7 +4960,7 @@
           <p:cNvPr id="1" name="">
             <a:extLst xmlns:a="http://schemas.openxmlformats.org/drawingml/2006/main">
               <a:ext uri="{FF2B5EF4-FFF2-40B4-BE49-F238E27FC236}">
-                <a16:creationId xmlns:a16="http://schemas.microsoft.com/office/drawing/2014/main" id="{9C1D5F19-CA8D-484A-97E1-F01BF809E930}"/>
+                <a16:creationId xmlns:a16="http://schemas.microsoft.com/office/drawing/2014/main" id="{DB2292E2-57C1-42FD-8A35-C28A2CCB4185}"/>
               </a:ext>
             </a:extLst>
           </p:cNvPr>
@@ -4927,7 +5016,7 @@
           <p:cNvPr id="2" name="">
             <a:extLst xmlns:a="http://schemas.openxmlformats.org/drawingml/2006/main">
               <a:ext uri="{FF2B5EF4-FFF2-40B4-BE49-F238E27FC236}">
-                <a16:creationId xmlns:a16="http://schemas.microsoft.com/office/drawing/2014/main" id="{FFE434FC-EB07-4EA5-B35A-192F90E1051F}"/>
+                <a16:creationId xmlns:a16="http://schemas.microsoft.com/office/drawing/2014/main" id="{1EE95374-3C2A-4B47-8A17-239685198E96}"/>
               </a:ext>
             </a:extLst>
           </p:cNvPr>
@@ -4983,7 +5072,7 @@
           <p:cNvPr id="3" name="">
             <a:extLst xmlns:a="http://schemas.openxmlformats.org/drawingml/2006/main">
               <a:ext uri="{FF2B5EF4-FFF2-40B4-BE49-F238E27FC236}">
-                <a16:creationId xmlns:a16="http://schemas.microsoft.com/office/drawing/2014/main" id="{D2ABC326-3C03-4554-9A18-77255B152337}"/>
+                <a16:creationId xmlns:a16="http://schemas.microsoft.com/office/drawing/2014/main" id="{2759AD01-9E37-4DF1-B7F5-A7046BB485E1}"/>
               </a:ext>
             </a:extLst>
           </p:cNvPr>
@@ -5039,7 +5128,7 @@
           <p:cNvPr id="4" name="">
             <a:extLst xmlns:a="http://schemas.openxmlformats.org/drawingml/2006/main">
               <a:ext uri="{FF2B5EF4-FFF2-40B4-BE49-F238E27FC236}">
-                <a16:creationId xmlns:a16="http://schemas.microsoft.com/office/drawing/2014/main" id="{CAC85E94-F4DC-481A-941D-57BB2BA9D4CA}"/>
+                <a16:creationId xmlns:a16="http://schemas.microsoft.com/office/drawing/2014/main" id="{11992CA1-C635-4678-AE91-F2B465647411}"/>
               </a:ext>
             </a:extLst>
           </p:cNvPr>
@@ -5095,7 +5184,7 @@
           <p:cNvPr id="5" name="">
             <a:extLst xmlns:a="http://schemas.openxmlformats.org/drawingml/2006/main">
               <a:ext uri="{FF2B5EF4-FFF2-40B4-BE49-F238E27FC236}">
-                <a16:creationId xmlns:a16="http://schemas.microsoft.com/office/drawing/2014/main" id="{9A636E20-11DA-444B-B000-2C4E38A8EF82}"/>
+                <a16:creationId xmlns:a16="http://schemas.microsoft.com/office/drawing/2014/main" id="{CF28080D-AEAA-493B-ABC8-8E9B773AB272}"/>
               </a:ext>
             </a:extLst>
           </p:cNvPr>
@@ -5130,7 +5219,7 @@
           <p:cNvPr id="6" name="">
             <a:extLst xmlns:a="http://schemas.openxmlformats.org/drawingml/2006/main">
               <a:ext uri="{FF2B5EF4-FFF2-40B4-BE49-F238E27FC236}">
-                <a16:creationId xmlns:a16="http://schemas.microsoft.com/office/drawing/2014/main" id="{42A6C2A0-E1BE-4531-8C4E-005191424C05}"/>
+                <a16:creationId xmlns:a16="http://schemas.microsoft.com/office/drawing/2014/main" id="{652BD963-697E-4C9E-B1B8-B1CA430189E7}"/>
               </a:ext>
             </a:extLst>
           </p:cNvPr>
@@ -5186,7 +5275,7 @@
           <p:cNvPr id="7" name="">
             <a:extLst xmlns:a="http://schemas.openxmlformats.org/drawingml/2006/main">
               <a:ext uri="{FF2B5EF4-FFF2-40B4-BE49-F238E27FC236}">
-                <a16:creationId xmlns:a16="http://schemas.microsoft.com/office/drawing/2014/main" id="{A928B2EB-E76F-4E58-8EDA-E65D74FB10EC}"/>
+                <a16:creationId xmlns:a16="http://schemas.microsoft.com/office/drawing/2014/main" id="{231DB56E-B38B-47D4-B2EE-7B2F2FC02FF8}"/>
               </a:ext>
             </a:extLst>
           </p:cNvPr>
@@ -5242,7 +5331,7 @@
           <p:cNvPr id="8" name="">
             <a:extLst xmlns:a="http://schemas.openxmlformats.org/drawingml/2006/main">
               <a:ext uri="{FF2B5EF4-FFF2-40B4-BE49-F238E27FC236}">
-                <a16:creationId xmlns:a16="http://schemas.microsoft.com/office/drawing/2014/main" id="{8CF8B342-7915-4945-AF9A-998DFDF3A091}"/>
+                <a16:creationId xmlns:a16="http://schemas.microsoft.com/office/drawing/2014/main" id="{FCBA8622-E4EC-4DE2-A494-002720307021}"/>
               </a:ext>
             </a:extLst>
           </p:cNvPr>
@@ -5298,7 +5387,7 @@
           <p:cNvPr id="9" name="">
             <a:extLst xmlns:a="http://schemas.openxmlformats.org/drawingml/2006/main">
               <a:ext uri="{FF2B5EF4-FFF2-40B4-BE49-F238E27FC236}">
-                <a16:creationId xmlns:a16="http://schemas.microsoft.com/office/drawing/2014/main" id="{65640407-9F68-4E8D-9849-93BD0BBEF597}"/>
+                <a16:creationId xmlns:a16="http://schemas.microsoft.com/office/drawing/2014/main" id="{50A124F4-7E0B-47D4-A55C-DD73027ED481}"/>
               </a:ext>
             </a:extLst>
           </p:cNvPr>
@@ -5354,7 +5443,7 @@
           <p:cNvPr id="10" name="">
             <a:extLst xmlns:a="http://schemas.openxmlformats.org/drawingml/2006/main">
               <a:ext uri="{FF2B5EF4-FFF2-40B4-BE49-F238E27FC236}">
-                <a16:creationId xmlns:a16="http://schemas.microsoft.com/office/drawing/2014/main" id="{B8B54962-693C-4424-B1A7-AD12AAFD6E1E}"/>
+                <a16:creationId xmlns:a16="http://schemas.microsoft.com/office/drawing/2014/main" id="{F4169037-AB10-44EB-8412-05BFE84586A8}"/>
               </a:ext>
             </a:extLst>
           </p:cNvPr>
@@ -5387,7 +5476,7 @@
           <p:cNvPr id="11" name="">
             <a:extLst xmlns:a="http://schemas.openxmlformats.org/drawingml/2006/main">
               <a:ext uri="{FF2B5EF4-FFF2-40B4-BE49-F238E27FC236}">
-                <a16:creationId xmlns:a16="http://schemas.microsoft.com/office/drawing/2014/main" id="{0E01180A-C208-44DB-A23C-BCB0EF4CA649}"/>
+                <a16:creationId xmlns:a16="http://schemas.microsoft.com/office/drawing/2014/main" id="{187A0448-9FC4-4798-A3F8-DAA602A23763}"/>
               </a:ext>
             </a:extLst>
           </p:cNvPr>
@@ -5443,7 +5532,7 @@
           <p:cNvPr id="12" name="">
             <a:extLst xmlns:a="http://schemas.openxmlformats.org/drawingml/2006/main">
               <a:ext uri="{FF2B5EF4-FFF2-40B4-BE49-F238E27FC236}">
-                <a16:creationId xmlns:a16="http://schemas.microsoft.com/office/drawing/2014/main" id="{D3711A6C-5A6C-4924-97A7-E9CCD2B7A579}"/>
+                <a16:creationId xmlns:a16="http://schemas.microsoft.com/office/drawing/2014/main" id="{622C970A-15E3-4A2B-9F7E-33E3BC345B5C}"/>
               </a:ext>
             </a:extLst>
           </p:cNvPr>
@@ -5476,7 +5565,7 @@
           <p:cNvPr id="13" name="">
             <a:extLst xmlns:a="http://schemas.openxmlformats.org/drawingml/2006/main">
               <a:ext uri="{FF2B5EF4-FFF2-40B4-BE49-F238E27FC236}">
-                <a16:creationId xmlns:a16="http://schemas.microsoft.com/office/drawing/2014/main" id="{7FA86087-627C-4F66-A8CA-B2EC4218BFB4}"/>
+                <a16:creationId xmlns:a16="http://schemas.microsoft.com/office/drawing/2014/main" id="{3BE116C1-ABE8-48A3-BC63-3EA29B0696F7}"/>
               </a:ext>
             </a:extLst>
           </p:cNvPr>
@@ -5532,7 +5621,7 @@
           <p:cNvPr id="14" name="">
             <a:extLst xmlns:a="http://schemas.openxmlformats.org/drawingml/2006/main">
               <a:ext uri="{FF2B5EF4-FFF2-40B4-BE49-F238E27FC236}">
-                <a16:creationId xmlns:a16="http://schemas.microsoft.com/office/drawing/2014/main" id="{66625406-0934-4C17-A41D-3FAF0FAB4422}"/>
+                <a16:creationId xmlns:a16="http://schemas.microsoft.com/office/drawing/2014/main" id="{E3756F95-51E8-4363-8548-797023DBA07C}"/>
               </a:ext>
             </a:extLst>
           </p:cNvPr>
@@ -5565,7 +5654,7 @@
           <p:cNvPr id="15" name="">
             <a:extLst xmlns:a="http://schemas.openxmlformats.org/drawingml/2006/main">
               <a:ext uri="{FF2B5EF4-FFF2-40B4-BE49-F238E27FC236}">
-                <a16:creationId xmlns:a16="http://schemas.microsoft.com/office/drawing/2014/main" id="{1B47AAFA-76D1-4667-9E06-DF8C3FFFDB44}"/>
+                <a16:creationId xmlns:a16="http://schemas.microsoft.com/office/drawing/2014/main" id="{800B5926-8166-4E16-8245-EB53BD7187F8}"/>
               </a:ext>
             </a:extLst>
           </p:cNvPr>
@@ -5621,7 +5710,7 @@
           <p:cNvPr id="16" name="">
             <a:extLst xmlns:a="http://schemas.openxmlformats.org/drawingml/2006/main">
               <a:ext uri="{FF2B5EF4-FFF2-40B4-BE49-F238E27FC236}">
-                <a16:creationId xmlns:a16="http://schemas.microsoft.com/office/drawing/2014/main" id="{A3BE27E2-4964-4454-94F6-6BD89E688121}"/>
+                <a16:creationId xmlns:a16="http://schemas.microsoft.com/office/drawing/2014/main" id="{9C899262-622F-4928-99A2-1EBF83DAD054}"/>
               </a:ext>
             </a:extLst>
           </p:cNvPr>
@@ -5654,7 +5743,7 @@
           <p:cNvPr id="17" name="">
             <a:extLst xmlns:a="http://schemas.openxmlformats.org/drawingml/2006/main">
               <a:ext uri="{FF2B5EF4-FFF2-40B4-BE49-F238E27FC236}">
-                <a16:creationId xmlns:a16="http://schemas.microsoft.com/office/drawing/2014/main" id="{245B7277-D3A1-4F48-AF83-E12CDE52F8F0}"/>
+                <a16:creationId xmlns:a16="http://schemas.microsoft.com/office/drawing/2014/main" id="{B6F539CC-6B23-4E7B-B7A0-684D584A5319}"/>
               </a:ext>
             </a:extLst>
           </p:cNvPr>
@@ -5708,7 +5797,7 @@
     </p:spTree>
     <p:extLst>
       <p:ext uri="{BB962C8B-B14F-4D97-AF65-F5344CB8AC3E}">
-        <p14:creationId xmlns:p14="http://schemas.microsoft.com/office/powerpoint/2010/main" val="2118183127"/>
+        <p14:creationId xmlns:p14="http://schemas.microsoft.com/office/powerpoint/2010/main" val="1574423201"/>
       </p:ext>
     </p:extLst>
   </p:cSld>
@@ -5739,7 +5828,7 @@
           <p:cNvPr id="1" name="">
             <a:extLst xmlns:a="http://schemas.openxmlformats.org/drawingml/2006/main">
               <a:ext uri="{FF2B5EF4-FFF2-40B4-BE49-F238E27FC236}">
-                <a16:creationId xmlns:a16="http://schemas.microsoft.com/office/drawing/2014/main" id="{770D46DE-AC62-4FE9-BB76-127ADFEE3A5B}"/>
+                <a16:creationId xmlns:a16="http://schemas.microsoft.com/office/drawing/2014/main" id="{3916461A-70E4-46AA-B96E-81454F836845}"/>
               </a:ext>
             </a:extLst>
           </p:cNvPr>
@@ -5795,7 +5884,7 @@
           <p:cNvPr id="2" name="">
             <a:extLst xmlns:a="http://schemas.openxmlformats.org/drawingml/2006/main">
               <a:ext uri="{FF2B5EF4-FFF2-40B4-BE49-F238E27FC236}">
-                <a16:creationId xmlns:a16="http://schemas.microsoft.com/office/drawing/2014/main" id="{70578448-E933-49E8-A4B7-83C7EADC30F2}"/>
+                <a16:creationId xmlns:a16="http://schemas.microsoft.com/office/drawing/2014/main" id="{DE666282-3AB6-4E02-8D19-9BB9F8BB8E05}"/>
               </a:ext>
             </a:extLst>
           </p:cNvPr>
@@ -5851,7 +5940,7 @@
           <p:cNvPr id="3" name="">
             <a:extLst xmlns:a="http://schemas.openxmlformats.org/drawingml/2006/main">
               <a:ext uri="{FF2B5EF4-FFF2-40B4-BE49-F238E27FC236}">
-                <a16:creationId xmlns:a16="http://schemas.microsoft.com/office/drawing/2014/main" id="{871BBEEF-A517-4F1A-8032-D0AEB1583B05}"/>
+                <a16:creationId xmlns:a16="http://schemas.microsoft.com/office/drawing/2014/main" id="{F01CD772-D68A-4C54-9192-8BD9900EA267}"/>
               </a:ext>
             </a:extLst>
           </p:cNvPr>
@@ -5907,7 +5996,7 @@
           <p:cNvPr id="4" name="">
             <a:extLst xmlns:a="http://schemas.openxmlformats.org/drawingml/2006/main">
               <a:ext uri="{FF2B5EF4-FFF2-40B4-BE49-F238E27FC236}">
-                <a16:creationId xmlns:a16="http://schemas.microsoft.com/office/drawing/2014/main" id="{E93A9B9A-8277-4250-B36E-89FE09DBF604}"/>
+                <a16:creationId xmlns:a16="http://schemas.microsoft.com/office/drawing/2014/main" id="{4A183FBF-DD30-4896-BBDF-DDF530E7556E}"/>
               </a:ext>
             </a:extLst>
           </p:cNvPr>
@@ -5963,7 +6052,7 @@
           <p:cNvPr id="5" name="">
             <a:extLst xmlns:a="http://schemas.openxmlformats.org/drawingml/2006/main">
               <a:ext uri="{FF2B5EF4-FFF2-40B4-BE49-F238E27FC236}">
-                <a16:creationId xmlns:a16="http://schemas.microsoft.com/office/drawing/2014/main" id="{A0BA79DD-AD9A-44B3-BD85-BA61D3255382}"/>
+                <a16:creationId xmlns:a16="http://schemas.microsoft.com/office/drawing/2014/main" id="{E08F14D1-632B-48FC-8C55-C70927CCCCDB}"/>
               </a:ext>
             </a:extLst>
           </p:cNvPr>
@@ -5998,7 +6087,7 @@
           <p:cNvPr id="6" name="">
             <a:extLst xmlns:a="http://schemas.openxmlformats.org/drawingml/2006/main">
               <a:ext uri="{FF2B5EF4-FFF2-40B4-BE49-F238E27FC236}">
-                <a16:creationId xmlns:a16="http://schemas.microsoft.com/office/drawing/2014/main" id="{638A3FC2-4A41-4BAA-8CC4-03F1DBD8FCD6}"/>
+                <a16:creationId xmlns:a16="http://schemas.microsoft.com/office/drawing/2014/main" id="{7146954A-CE4D-43AC-AD01-178D55E4FF4C}"/>
               </a:ext>
             </a:extLst>
           </p:cNvPr>
@@ -6054,7 +6143,7 @@
           <p:cNvPr id="7" name="">
             <a:extLst xmlns:a="http://schemas.openxmlformats.org/drawingml/2006/main">
               <a:ext uri="{FF2B5EF4-FFF2-40B4-BE49-F238E27FC236}">
-                <a16:creationId xmlns:a16="http://schemas.microsoft.com/office/drawing/2014/main" id="{CF813054-23E2-4C06-B3A7-E25DBB476ABC}"/>
+                <a16:creationId xmlns:a16="http://schemas.microsoft.com/office/drawing/2014/main" id="{42A70B22-E3CC-460C-ABB2-F2DF4B718A76}"/>
               </a:ext>
             </a:extLst>
           </p:cNvPr>
@@ -6110,7 +6199,7 @@
           <p:cNvPr id="8" name="">
             <a:extLst xmlns:a="http://schemas.openxmlformats.org/drawingml/2006/main">
               <a:ext uri="{FF2B5EF4-FFF2-40B4-BE49-F238E27FC236}">
-                <a16:creationId xmlns:a16="http://schemas.microsoft.com/office/drawing/2014/main" id="{DBEA41D5-93FE-4013-871A-3E7EF2667E2A}"/>
+                <a16:creationId xmlns:a16="http://schemas.microsoft.com/office/drawing/2014/main" id="{08D19FB6-61EF-4859-9D75-9E7B8BBCA2EC}"/>
               </a:ext>
             </a:extLst>
           </p:cNvPr>
@@ -6166,7 +6255,7 @@
           <p:cNvPr id="9" name="">
             <a:extLst xmlns:a="http://schemas.openxmlformats.org/drawingml/2006/main">
               <a:ext uri="{FF2B5EF4-FFF2-40B4-BE49-F238E27FC236}">
-                <a16:creationId xmlns:a16="http://schemas.microsoft.com/office/drawing/2014/main" id="{AD1BAB00-36AE-4FED-8D23-195A00B46DA7}"/>
+                <a16:creationId xmlns:a16="http://schemas.microsoft.com/office/drawing/2014/main" id="{2824172B-9807-4281-AF50-2EF8A42FAB23}"/>
               </a:ext>
             </a:extLst>
           </p:cNvPr>
@@ -6212,7 +6301,7 @@
                 <a:ea typeface="Aptos"/>
                 <a:cs typeface="Aptos"/>
               </a:rPr>
-              <a:t>Reception and retail.</a:t>
+              <a:t>Target location: 6000 Merriweather Drive.</a:t>
             </a:r>
           </a:p>
         </p:txBody>
@@ -6222,7 +6311,7 @@
           <p:cNvPr id="10" name="">
             <a:extLst xmlns:a="http://schemas.openxmlformats.org/drawingml/2006/main">
               <a:ext uri="{FF2B5EF4-FFF2-40B4-BE49-F238E27FC236}">
-                <a16:creationId xmlns:a16="http://schemas.microsoft.com/office/drawing/2014/main" id="{D3EF8A2C-2A43-4865-BF52-286D399E8B1B}"/>
+                <a16:creationId xmlns:a16="http://schemas.microsoft.com/office/drawing/2014/main" id="{10444B66-ACFD-4C9F-AC6C-F0A54063B8D5}"/>
               </a:ext>
             </a:extLst>
           </p:cNvPr>
@@ -6255,7 +6344,7 @@
           <p:cNvPr id="11" name="">
             <a:extLst xmlns:a="http://schemas.openxmlformats.org/drawingml/2006/main">
               <a:ext uri="{FF2B5EF4-FFF2-40B4-BE49-F238E27FC236}">
-                <a16:creationId xmlns:a16="http://schemas.microsoft.com/office/drawing/2014/main" id="{195D1606-A642-44E9-B6DD-C633A637768E}"/>
+                <a16:creationId xmlns:a16="http://schemas.microsoft.com/office/drawing/2014/main" id="{2B7C36BE-35D5-47CA-90CA-37F9D7DD706C}"/>
               </a:ext>
             </a:extLst>
           </p:cNvPr>
@@ -6301,7 +6390,7 @@
                 <a:ea typeface="Aptos"/>
                 <a:cs typeface="Aptos"/>
               </a:rPr>
-              <a:t>IV/NAD lounge.</a:t>
+              <a:t>Reception and retail.</a:t>
             </a:r>
           </a:p>
         </p:txBody>
@@ -6311,7 +6400,7 @@
           <p:cNvPr id="12" name="">
             <a:extLst xmlns:a="http://schemas.openxmlformats.org/drawingml/2006/main">
               <a:ext uri="{FF2B5EF4-FFF2-40B4-BE49-F238E27FC236}">
-                <a16:creationId xmlns:a16="http://schemas.microsoft.com/office/drawing/2014/main" id="{F60DDD1A-BA03-4F36-A9FC-B68950EFC7CC}"/>
+                <a16:creationId xmlns:a16="http://schemas.microsoft.com/office/drawing/2014/main" id="{DBFC50B5-D100-4D4C-AB48-88B91846F59A}"/>
               </a:ext>
             </a:extLst>
           </p:cNvPr>
@@ -6344,7 +6433,7 @@
           <p:cNvPr id="13" name="">
             <a:extLst xmlns:a="http://schemas.openxmlformats.org/drawingml/2006/main">
               <a:ext uri="{FF2B5EF4-FFF2-40B4-BE49-F238E27FC236}">
-                <a16:creationId xmlns:a16="http://schemas.microsoft.com/office/drawing/2014/main" id="{78CA5D8B-113C-4439-B809-6738E2357CD7}"/>
+                <a16:creationId xmlns:a16="http://schemas.microsoft.com/office/drawing/2014/main" id="{34FB33D9-42EF-4BE9-B968-E798B1F04D9E}"/>
               </a:ext>
             </a:extLst>
           </p:cNvPr>
@@ -6390,7 +6479,7 @@
                 <a:ea typeface="Aptos"/>
                 <a:cs typeface="Aptos"/>
               </a:rPr>
-              <a:t>Consult rooms.</a:t>
+              <a:t>IV/NAD lounge.</a:t>
             </a:r>
           </a:p>
         </p:txBody>
@@ -6400,7 +6489,7 @@
           <p:cNvPr id="14" name="">
             <a:extLst xmlns:a="http://schemas.openxmlformats.org/drawingml/2006/main">
               <a:ext uri="{FF2B5EF4-FFF2-40B4-BE49-F238E27FC236}">
-                <a16:creationId xmlns:a16="http://schemas.microsoft.com/office/drawing/2014/main" id="{2DFB0B83-3742-4754-9499-6192919C2110}"/>
+                <a16:creationId xmlns:a16="http://schemas.microsoft.com/office/drawing/2014/main" id="{84C9080E-A37A-41CB-9138-17A76AAEFD5E}"/>
               </a:ext>
             </a:extLst>
           </p:cNvPr>
@@ -6433,7 +6522,7 @@
           <p:cNvPr id="15" name="">
             <a:extLst xmlns:a="http://schemas.openxmlformats.org/drawingml/2006/main">
               <a:ext uri="{FF2B5EF4-FFF2-40B4-BE49-F238E27FC236}">
-                <a16:creationId xmlns:a16="http://schemas.microsoft.com/office/drawing/2014/main" id="{20FF5E7B-FA0E-4E7F-A942-0ED7685520F6}"/>
+                <a16:creationId xmlns:a16="http://schemas.microsoft.com/office/drawing/2014/main" id="{B18BBCF7-F318-4AC0-BC75-CCD99162C187}"/>
               </a:ext>
             </a:extLst>
           </p:cNvPr>
@@ -6479,7 +6568,7 @@
                 <a:ea typeface="Aptos"/>
                 <a:cs typeface="Aptos"/>
               </a:rPr>
-              <a:t>Cryotherapy, red light, sauna/cold plunge, recovery zone.</a:t>
+              <a:t>Consult rooms.</a:t>
             </a:r>
           </a:p>
         </p:txBody>
@@ -6489,7 +6578,7 @@
           <p:cNvPr id="16" name="">
             <a:extLst xmlns:a="http://schemas.openxmlformats.org/drawingml/2006/main">
               <a:ext uri="{FF2B5EF4-FFF2-40B4-BE49-F238E27FC236}">
-                <a16:creationId xmlns:a16="http://schemas.microsoft.com/office/drawing/2014/main" id="{BA7A2840-B162-4557-B3BE-33332B22D543}"/>
+                <a16:creationId xmlns:a16="http://schemas.microsoft.com/office/drawing/2014/main" id="{D7C7B13D-AFA5-477C-81AB-0BFA5CBF89A4}"/>
               </a:ext>
             </a:extLst>
           </p:cNvPr>
@@ -6522,7 +6611,96 @@
           <p:cNvPr id="17" name="">
             <a:extLst xmlns:a="http://schemas.openxmlformats.org/drawingml/2006/main">
               <a:ext uri="{FF2B5EF4-FFF2-40B4-BE49-F238E27FC236}">
-                <a16:creationId xmlns:a16="http://schemas.microsoft.com/office/drawing/2014/main" id="{F3D569EE-CE78-466E-9A64-03E2E4064292}"/>
+                <a16:creationId xmlns:a16="http://schemas.microsoft.com/office/drawing/2014/main" id="{779C5F05-10EB-48AC-9E50-0F93EE888A31}"/>
+              </a:ext>
+            </a:extLst>
+          </p:cNvPr>
+          <p:cNvSpPr>
+            <a:spLocks xmlns:a="http://schemas.openxmlformats.org/drawingml/2006/main" noGrp="1"/>
+          </p:cNvSpPr>
+          <p:nvPr/>
+        </p:nvSpPr>
+        <p:spPr>
+          <a:xfrm xmlns:a="http://schemas.openxmlformats.org/drawingml/2006/main">
+            <a:off x="838200" y="4724400"/>
+            <a:ext cx="5638800" cy="323850"/>
+          </a:xfrm>
+          <a:prstGeom xmlns:a="http://schemas.openxmlformats.org/drawingml/2006/main" prst="rect">
+            <a:avLst/>
+          </a:prstGeom>
+          <a:noFill xmlns:a="http://schemas.openxmlformats.org/drawingml/2006/main"/>
+          <a:ln xmlns:a="http://schemas.openxmlformats.org/drawingml/2006/main" w="0">
+            <a:noFill/>
+            <a:prstDash val="solid"/>
+          </a:ln>
+        </p:spPr>
+        <p:txBody>
+          <a:bodyPr xmlns:a="http://schemas.openxmlformats.org/drawingml/2006/main"/>
+          <a:lstStyle xmlns:a="http://schemas.openxmlformats.org/drawingml/2006/main"/>
+          <a:p xmlns:a="http://schemas.openxmlformats.org/drawingml/2006/main">
+            <a:pPr>
+              <a:defRPr sz="1425">
+                <a:solidFill>
+                  <a:srgbClr val="F6F0E6"/>
+                </a:solidFill>
+                <a:latin typeface="Aptos"/>
+                <a:ea typeface="Aptos"/>
+                <a:cs typeface="Aptos"/>
+              </a:defRPr>
+            </a:pPr>
+            <a:r>
+              <a:rPr sz="1425">
+                <a:solidFill>
+                  <a:srgbClr val="F6F0E6"/>
+                </a:solidFill>
+                <a:latin typeface="Aptos"/>
+                <a:ea typeface="Aptos"/>
+                <a:cs typeface="Aptos"/>
+              </a:rPr>
+              <a:t>Cryotherapy, red light, sauna/cold plunge, recovery zone.</a:t>
+            </a:r>
+          </a:p>
+        </p:txBody>
+      </p:sp>
+      <p:sp>
+        <p:nvSpPr>
+          <p:cNvPr id="18" name="">
+            <a:extLst xmlns:a="http://schemas.openxmlformats.org/drawingml/2006/main">
+              <a:ext uri="{FF2B5EF4-FFF2-40B4-BE49-F238E27FC236}">
+                <a16:creationId xmlns:a16="http://schemas.microsoft.com/office/drawing/2014/main" id="{407F17A8-4B69-446A-B634-A0708671C452}"/>
+              </a:ext>
+            </a:extLst>
+          </p:cNvPr>
+          <p:cNvSpPr>
+            <a:spLocks xmlns:a="http://schemas.openxmlformats.org/drawingml/2006/main" noGrp="1"/>
+          </p:cNvSpPr>
+          <p:nvPr/>
+        </p:nvSpPr>
+        <p:spPr>
+          <a:xfrm xmlns:a="http://schemas.openxmlformats.org/drawingml/2006/main">
+            <a:off x="628650" y="4800600"/>
+            <a:ext cx="76200" cy="76200"/>
+          </a:xfrm>
+          <a:prstGeom xmlns:a="http://schemas.openxmlformats.org/drawingml/2006/main" prst="ellipse">
+            <a:avLst/>
+          </a:prstGeom>
+          <a:solidFill xmlns:a="http://schemas.openxmlformats.org/drawingml/2006/main">
+            <a:srgbClr val="C8A46B"/>
+          </a:solidFill>
+          <a:ln xmlns:a="http://schemas.openxmlformats.org/drawingml/2006/main" w="9525">
+            <a:solidFill>
+              <a:srgbClr val="C8A46B"/>
+            </a:solidFill>
+            <a:prstDash val="solid"/>
+          </a:ln>
+        </p:spPr>
+      </p:sp>
+      <p:sp>
+        <p:nvSpPr>
+          <p:cNvPr id="19" name="">
+            <a:extLst xmlns:a="http://schemas.openxmlformats.org/drawingml/2006/main">
+              <a:ext uri="{FF2B5EF4-FFF2-40B4-BE49-F238E27FC236}">
+                <a16:creationId xmlns:a16="http://schemas.microsoft.com/office/drawing/2014/main" id="{8DB3E655-323E-4E13-8FEC-90DC4C984CDB}"/>
               </a:ext>
             </a:extLst>
           </p:cNvPr>
@@ -6576,7 +6754,7 @@
     </p:spTree>
     <p:extLst>
       <p:ext uri="{BB962C8B-B14F-4D97-AF65-F5344CB8AC3E}">
-        <p14:creationId xmlns:p14="http://schemas.microsoft.com/office/powerpoint/2010/main" val="1938344826"/>
+        <p14:creationId xmlns:p14="http://schemas.microsoft.com/office/powerpoint/2010/main" val="1952825088"/>
       </p:ext>
     </p:extLst>
   </p:cSld>
@@ -6607,7 +6785,7 @@
           <p:cNvPr id="1" name="">
             <a:extLst xmlns:a="http://schemas.openxmlformats.org/drawingml/2006/main">
               <a:ext uri="{FF2B5EF4-FFF2-40B4-BE49-F238E27FC236}">
-                <a16:creationId xmlns:a16="http://schemas.microsoft.com/office/drawing/2014/main" id="{03EC7192-1A8D-49B1-995A-7D2171336E2B}"/>
+                <a16:creationId xmlns:a16="http://schemas.microsoft.com/office/drawing/2014/main" id="{640217C7-9F17-47D4-A024-BD15E739D5C6}"/>
               </a:ext>
             </a:extLst>
           </p:cNvPr>
@@ -6663,7 +6841,7 @@
           <p:cNvPr id="2" name="">
             <a:extLst xmlns:a="http://schemas.openxmlformats.org/drawingml/2006/main">
               <a:ext uri="{FF2B5EF4-FFF2-40B4-BE49-F238E27FC236}">
-                <a16:creationId xmlns:a16="http://schemas.microsoft.com/office/drawing/2014/main" id="{02057896-AE43-44D0-8832-998E83473071}"/>
+                <a16:creationId xmlns:a16="http://schemas.microsoft.com/office/drawing/2014/main" id="{6597EBFE-B045-4E13-AB49-57D03CC09FE0}"/>
               </a:ext>
             </a:extLst>
           </p:cNvPr>
@@ -6719,7 +6897,7 @@
           <p:cNvPr id="3" name="">
             <a:extLst xmlns:a="http://schemas.openxmlformats.org/drawingml/2006/main">
               <a:ext uri="{FF2B5EF4-FFF2-40B4-BE49-F238E27FC236}">
-                <a16:creationId xmlns:a16="http://schemas.microsoft.com/office/drawing/2014/main" id="{BF85DC3C-CCFE-4B61-99CE-EF079B663543}"/>
+                <a16:creationId xmlns:a16="http://schemas.microsoft.com/office/drawing/2014/main" id="{6A0DE242-1A5E-430C-A2E8-E1BBA4CC34D6}"/>
               </a:ext>
             </a:extLst>
           </p:cNvPr>
@@ -6775,7 +6953,7 @@
           <p:cNvPr id="4" name="">
             <a:extLst xmlns:a="http://schemas.openxmlformats.org/drawingml/2006/main">
               <a:ext uri="{FF2B5EF4-FFF2-40B4-BE49-F238E27FC236}">
-                <a16:creationId xmlns:a16="http://schemas.microsoft.com/office/drawing/2014/main" id="{B37A7124-A868-4CAD-ACE7-35179DE9E4E6}"/>
+                <a16:creationId xmlns:a16="http://schemas.microsoft.com/office/drawing/2014/main" id="{AD1B3F0D-7F92-487E-A742-B6E82B1BE512}"/>
               </a:ext>
             </a:extLst>
           </p:cNvPr>
@@ -6831,7 +7009,7 @@
           <p:cNvPr id="5" name="">
             <a:extLst xmlns:a="http://schemas.openxmlformats.org/drawingml/2006/main">
               <a:ext uri="{FF2B5EF4-FFF2-40B4-BE49-F238E27FC236}">
-                <a16:creationId xmlns:a16="http://schemas.microsoft.com/office/drawing/2014/main" id="{AC5CE2F0-3455-4E8A-9968-F5370DFD7408}"/>
+                <a16:creationId xmlns:a16="http://schemas.microsoft.com/office/drawing/2014/main" id="{4025445C-DC39-4F34-B740-8A6D9252CC39}"/>
               </a:ext>
             </a:extLst>
           </p:cNvPr>
@@ -6866,7 +7044,7 @@
           <p:cNvPr id="6" name="">
             <a:extLst xmlns:a="http://schemas.openxmlformats.org/drawingml/2006/main">
               <a:ext uri="{FF2B5EF4-FFF2-40B4-BE49-F238E27FC236}">
-                <a16:creationId xmlns:a16="http://schemas.microsoft.com/office/drawing/2014/main" id="{AAD8B5CF-F1AD-4F39-99FE-56CC43A74016}"/>
+                <a16:creationId xmlns:a16="http://schemas.microsoft.com/office/drawing/2014/main" id="{628D6419-8636-4B88-9D48-59DB33CDB65A}"/>
               </a:ext>
             </a:extLst>
           </p:cNvPr>
@@ -6922,7 +7100,7 @@
           <p:cNvPr id="7" name="">
             <a:extLst xmlns:a="http://schemas.openxmlformats.org/drawingml/2006/main">
               <a:ext uri="{FF2B5EF4-FFF2-40B4-BE49-F238E27FC236}">
-                <a16:creationId xmlns:a16="http://schemas.microsoft.com/office/drawing/2014/main" id="{D7622F1E-FF88-487A-8FB8-2DB3C791190F}"/>
+                <a16:creationId xmlns:a16="http://schemas.microsoft.com/office/drawing/2014/main" id="{561D40B2-1D18-4267-BAF9-42F65DB11C1E}"/>
               </a:ext>
             </a:extLst>
           </p:cNvPr>
@@ -6978,7 +7156,7 @@
           <p:cNvPr id="8" name="">
             <a:extLst xmlns:a="http://schemas.openxmlformats.org/drawingml/2006/main">
               <a:ext uri="{FF2B5EF4-FFF2-40B4-BE49-F238E27FC236}">
-                <a16:creationId xmlns:a16="http://schemas.microsoft.com/office/drawing/2014/main" id="{5831E519-AD19-4090-A7E0-5CEF127BA132}"/>
+                <a16:creationId xmlns:a16="http://schemas.microsoft.com/office/drawing/2014/main" id="{EC4C5726-0E76-4C89-9462-0F65482DC6E5}"/>
               </a:ext>
             </a:extLst>
           </p:cNvPr>
@@ -7034,7 +7212,7 @@
           <p:cNvPr id="9" name="">
             <a:extLst xmlns:a="http://schemas.openxmlformats.org/drawingml/2006/main">
               <a:ext uri="{FF2B5EF4-FFF2-40B4-BE49-F238E27FC236}">
-                <a16:creationId xmlns:a16="http://schemas.microsoft.com/office/drawing/2014/main" id="{3541ADCA-7A25-4F62-9269-8B86036AA8DD}"/>
+                <a16:creationId xmlns:a16="http://schemas.microsoft.com/office/drawing/2014/main" id="{B0823335-2FFE-490D-A347-236F84A66AD2}"/>
               </a:ext>
             </a:extLst>
           </p:cNvPr>
@@ -7090,7 +7268,7 @@
           <p:cNvPr id="10" name="">
             <a:extLst xmlns:a="http://schemas.openxmlformats.org/drawingml/2006/main">
               <a:ext uri="{FF2B5EF4-FFF2-40B4-BE49-F238E27FC236}">
-                <a16:creationId xmlns:a16="http://schemas.microsoft.com/office/drawing/2014/main" id="{405FBFE5-033A-4003-B680-3EF04980FB44}"/>
+                <a16:creationId xmlns:a16="http://schemas.microsoft.com/office/drawing/2014/main" id="{70AF7D4B-301A-49A6-83C7-AD040233441F}"/>
               </a:ext>
             </a:extLst>
           </p:cNvPr>
@@ -7123,7 +7301,7 @@
           <p:cNvPr id="11" name="">
             <a:extLst xmlns:a="http://schemas.openxmlformats.org/drawingml/2006/main">
               <a:ext uri="{FF2B5EF4-FFF2-40B4-BE49-F238E27FC236}">
-                <a16:creationId xmlns:a16="http://schemas.microsoft.com/office/drawing/2014/main" id="{B9E91220-7935-4C97-9BF9-62C44D04989A}"/>
+                <a16:creationId xmlns:a16="http://schemas.microsoft.com/office/drawing/2014/main" id="{4AB1C1B1-B81B-4B3C-8D46-AF4BC0BDA25E}"/>
               </a:ext>
             </a:extLst>
           </p:cNvPr>
@@ -7169,7 +7347,7 @@
                 <a:ea typeface="Aptos"/>
                 <a:cs typeface="Aptos"/>
               </a:rPr>
-              <a:t>Member app/PWA.</a:t>
+              <a:t>Local role login.</a:t>
             </a:r>
           </a:p>
         </p:txBody>
@@ -7179,7 +7357,7 @@
           <p:cNvPr id="12" name="">
             <a:extLst xmlns:a="http://schemas.openxmlformats.org/drawingml/2006/main">
               <a:ext uri="{FF2B5EF4-FFF2-40B4-BE49-F238E27FC236}">
-                <a16:creationId xmlns:a16="http://schemas.microsoft.com/office/drawing/2014/main" id="{E815E269-013B-4515-AA9A-190FA50954EF}"/>
+                <a16:creationId xmlns:a16="http://schemas.microsoft.com/office/drawing/2014/main" id="{340D3810-719B-4C05-A762-803F447E43C7}"/>
               </a:ext>
             </a:extLst>
           </p:cNvPr>
@@ -7212,7 +7390,7 @@
           <p:cNvPr id="13" name="">
             <a:extLst xmlns:a="http://schemas.openxmlformats.org/drawingml/2006/main">
               <a:ext uri="{FF2B5EF4-FFF2-40B4-BE49-F238E27FC236}">
-                <a16:creationId xmlns:a16="http://schemas.microsoft.com/office/drawing/2014/main" id="{7FE4AF16-4C81-403F-803F-2DBBF81CE8F6}"/>
+                <a16:creationId xmlns:a16="http://schemas.microsoft.com/office/drawing/2014/main" id="{A6FF45B9-C210-4A15-9B0F-154503D568EB}"/>
               </a:ext>
             </a:extLst>
           </p:cNvPr>
@@ -7258,7 +7436,7 @@
                 <a:ea typeface="Aptos"/>
                 <a:cs typeface="Aptos"/>
               </a:rPr>
-              <a:t>Admin dashboard.</a:t>
+              <a:t>Command portal.</a:t>
             </a:r>
           </a:p>
         </p:txBody>
@@ -7268,7 +7446,7 @@
           <p:cNvPr id="14" name="">
             <a:extLst xmlns:a="http://schemas.openxmlformats.org/drawingml/2006/main">
               <a:ext uri="{FF2B5EF4-FFF2-40B4-BE49-F238E27FC236}">
-                <a16:creationId xmlns:a16="http://schemas.microsoft.com/office/drawing/2014/main" id="{AE2D5789-4F96-4699-9D9B-14B56B8D71B6}"/>
+                <a16:creationId xmlns:a16="http://schemas.microsoft.com/office/drawing/2014/main" id="{AF72F202-9D3C-42B8-840E-DDB720CC1BCC}"/>
               </a:ext>
             </a:extLst>
           </p:cNvPr>
@@ -7301,7 +7479,7 @@
           <p:cNvPr id="15" name="">
             <a:extLst xmlns:a="http://schemas.openxmlformats.org/drawingml/2006/main">
               <a:ext uri="{FF2B5EF4-FFF2-40B4-BE49-F238E27FC236}">
-                <a16:creationId xmlns:a16="http://schemas.microsoft.com/office/drawing/2014/main" id="{B105C6E5-348D-4F1E-8F54-F403BDD7E024}"/>
+                <a16:creationId xmlns:a16="http://schemas.microsoft.com/office/drawing/2014/main" id="{938CA714-28CE-44DE-B7F5-A2F6722F4FD7}"/>
               </a:ext>
             </a:extLst>
           </p:cNvPr>
@@ -7347,7 +7525,7 @@
                 <a:ea typeface="Aptos"/>
                 <a:cs typeface="Aptos"/>
               </a:rPr>
-              <a:t>Vendor CRM and content calendar.</a:t>
+              <a:t>Member app/PWA.</a:t>
             </a:r>
           </a:p>
         </p:txBody>
@@ -7357,7 +7535,7 @@
           <p:cNvPr id="16" name="">
             <a:extLst xmlns:a="http://schemas.openxmlformats.org/drawingml/2006/main">
               <a:ext uri="{FF2B5EF4-FFF2-40B4-BE49-F238E27FC236}">
-                <a16:creationId xmlns:a16="http://schemas.microsoft.com/office/drawing/2014/main" id="{8F0BE72D-41C8-4F5F-880A-847AFC264F0E}"/>
+                <a16:creationId xmlns:a16="http://schemas.microsoft.com/office/drawing/2014/main" id="{ED44D6F5-7423-4C42-8A7D-C15DAA284AA1}"/>
               </a:ext>
             </a:extLst>
           </p:cNvPr>
@@ -7390,7 +7568,185 @@
           <p:cNvPr id="17" name="">
             <a:extLst xmlns:a="http://schemas.openxmlformats.org/drawingml/2006/main">
               <a:ext uri="{FF2B5EF4-FFF2-40B4-BE49-F238E27FC236}">
-                <a16:creationId xmlns:a16="http://schemas.microsoft.com/office/drawing/2014/main" id="{7DED6515-2EB2-43B0-8090-1FAAE8AD63A7}"/>
+                <a16:creationId xmlns:a16="http://schemas.microsoft.com/office/drawing/2014/main" id="{F3086C61-2805-4288-8A64-3491BE5B2875}"/>
+              </a:ext>
+            </a:extLst>
+          </p:cNvPr>
+          <p:cNvSpPr>
+            <a:spLocks xmlns:a="http://schemas.openxmlformats.org/drawingml/2006/main" noGrp="1"/>
+          </p:cNvSpPr>
+          <p:nvPr/>
+        </p:nvSpPr>
+        <p:spPr>
+          <a:xfrm xmlns:a="http://schemas.openxmlformats.org/drawingml/2006/main">
+            <a:off x="838200" y="4724400"/>
+            <a:ext cx="5638800" cy="323850"/>
+          </a:xfrm>
+          <a:prstGeom xmlns:a="http://schemas.openxmlformats.org/drawingml/2006/main" prst="rect">
+            <a:avLst/>
+          </a:prstGeom>
+          <a:noFill xmlns:a="http://schemas.openxmlformats.org/drawingml/2006/main"/>
+          <a:ln xmlns:a="http://schemas.openxmlformats.org/drawingml/2006/main" w="0">
+            <a:noFill/>
+            <a:prstDash val="solid"/>
+          </a:ln>
+        </p:spPr>
+        <p:txBody>
+          <a:bodyPr xmlns:a="http://schemas.openxmlformats.org/drawingml/2006/main"/>
+          <a:lstStyle xmlns:a="http://schemas.openxmlformats.org/drawingml/2006/main"/>
+          <a:p xmlns:a="http://schemas.openxmlformats.org/drawingml/2006/main">
+            <a:pPr>
+              <a:defRPr sz="1425">
+                <a:solidFill>
+                  <a:srgbClr val="F6F0E6"/>
+                </a:solidFill>
+                <a:latin typeface="Aptos"/>
+                <a:ea typeface="Aptos"/>
+                <a:cs typeface="Aptos"/>
+              </a:defRPr>
+            </a:pPr>
+            <a:r>
+              <a:rPr sz="1425">
+                <a:solidFill>
+                  <a:srgbClr val="F6F0E6"/>
+                </a:solidFill>
+                <a:latin typeface="Aptos"/>
+                <a:ea typeface="Aptos"/>
+                <a:cs typeface="Aptos"/>
+              </a:rPr>
+              <a:t>Admin dashboard.</a:t>
+            </a:r>
+          </a:p>
+        </p:txBody>
+      </p:sp>
+      <p:sp>
+        <p:nvSpPr>
+          <p:cNvPr id="18" name="">
+            <a:extLst xmlns:a="http://schemas.openxmlformats.org/drawingml/2006/main">
+              <a:ext uri="{FF2B5EF4-FFF2-40B4-BE49-F238E27FC236}">
+                <a16:creationId xmlns:a16="http://schemas.microsoft.com/office/drawing/2014/main" id="{2AF44B79-EB60-41AC-9E2C-FD42B059453B}"/>
+              </a:ext>
+            </a:extLst>
+          </p:cNvPr>
+          <p:cNvSpPr>
+            <a:spLocks xmlns:a="http://schemas.openxmlformats.org/drawingml/2006/main" noGrp="1"/>
+          </p:cNvSpPr>
+          <p:nvPr/>
+        </p:nvSpPr>
+        <p:spPr>
+          <a:xfrm xmlns:a="http://schemas.openxmlformats.org/drawingml/2006/main">
+            <a:off x="628650" y="4800600"/>
+            <a:ext cx="76200" cy="76200"/>
+          </a:xfrm>
+          <a:prstGeom xmlns:a="http://schemas.openxmlformats.org/drawingml/2006/main" prst="ellipse">
+            <a:avLst/>
+          </a:prstGeom>
+          <a:solidFill xmlns:a="http://schemas.openxmlformats.org/drawingml/2006/main">
+            <a:srgbClr val="C8A46B"/>
+          </a:solidFill>
+          <a:ln xmlns:a="http://schemas.openxmlformats.org/drawingml/2006/main" w="9525">
+            <a:solidFill>
+              <a:srgbClr val="C8A46B"/>
+            </a:solidFill>
+            <a:prstDash val="solid"/>
+          </a:ln>
+        </p:spPr>
+      </p:sp>
+      <p:sp>
+        <p:nvSpPr>
+          <p:cNvPr id="19" name="">
+            <a:extLst xmlns:a="http://schemas.openxmlformats.org/drawingml/2006/main">
+              <a:ext uri="{FF2B5EF4-FFF2-40B4-BE49-F238E27FC236}">
+                <a16:creationId xmlns:a16="http://schemas.microsoft.com/office/drawing/2014/main" id="{5BB18B4E-AC06-4D8C-8602-3E1D4DCF1B2F}"/>
+              </a:ext>
+            </a:extLst>
+          </p:cNvPr>
+          <p:cNvSpPr>
+            <a:spLocks xmlns:a="http://schemas.openxmlformats.org/drawingml/2006/main" noGrp="1"/>
+          </p:cNvSpPr>
+          <p:nvPr/>
+        </p:nvSpPr>
+        <p:spPr>
+          <a:xfrm xmlns:a="http://schemas.openxmlformats.org/drawingml/2006/main">
+            <a:off x="838200" y="5162550"/>
+            <a:ext cx="5638800" cy="323850"/>
+          </a:xfrm>
+          <a:prstGeom xmlns:a="http://schemas.openxmlformats.org/drawingml/2006/main" prst="rect">
+            <a:avLst/>
+          </a:prstGeom>
+          <a:noFill xmlns:a="http://schemas.openxmlformats.org/drawingml/2006/main"/>
+          <a:ln xmlns:a="http://schemas.openxmlformats.org/drawingml/2006/main" w="0">
+            <a:noFill/>
+            <a:prstDash val="solid"/>
+          </a:ln>
+        </p:spPr>
+        <p:txBody>
+          <a:bodyPr xmlns:a="http://schemas.openxmlformats.org/drawingml/2006/main"/>
+          <a:lstStyle xmlns:a="http://schemas.openxmlformats.org/drawingml/2006/main"/>
+          <a:p xmlns:a="http://schemas.openxmlformats.org/drawingml/2006/main">
+            <a:pPr>
+              <a:defRPr sz="1425">
+                <a:solidFill>
+                  <a:srgbClr val="F6F0E6"/>
+                </a:solidFill>
+                <a:latin typeface="Aptos"/>
+                <a:ea typeface="Aptos"/>
+                <a:cs typeface="Aptos"/>
+              </a:defRPr>
+            </a:pPr>
+            <a:r>
+              <a:rPr sz="1425">
+                <a:solidFill>
+                  <a:srgbClr val="F6F0E6"/>
+                </a:solidFill>
+                <a:latin typeface="Aptos"/>
+                <a:ea typeface="Aptos"/>
+                <a:cs typeface="Aptos"/>
+              </a:rPr>
+              <a:t>Vendor CRM and content calendar.</a:t>
+            </a:r>
+          </a:p>
+        </p:txBody>
+      </p:sp>
+      <p:sp>
+        <p:nvSpPr>
+          <p:cNvPr id="20" name="">
+            <a:extLst xmlns:a="http://schemas.openxmlformats.org/drawingml/2006/main">
+              <a:ext uri="{FF2B5EF4-FFF2-40B4-BE49-F238E27FC236}">
+                <a16:creationId xmlns:a16="http://schemas.microsoft.com/office/drawing/2014/main" id="{1D987923-AA10-48E1-A8E9-30A702C6CB7A}"/>
+              </a:ext>
+            </a:extLst>
+          </p:cNvPr>
+          <p:cNvSpPr>
+            <a:spLocks xmlns:a="http://schemas.openxmlformats.org/drawingml/2006/main" noGrp="1"/>
+          </p:cNvSpPr>
+          <p:nvPr/>
+        </p:nvSpPr>
+        <p:spPr>
+          <a:xfrm xmlns:a="http://schemas.openxmlformats.org/drawingml/2006/main">
+            <a:off x="628650" y="5238750"/>
+            <a:ext cx="76200" cy="76200"/>
+          </a:xfrm>
+          <a:prstGeom xmlns:a="http://schemas.openxmlformats.org/drawingml/2006/main" prst="ellipse">
+            <a:avLst/>
+          </a:prstGeom>
+          <a:solidFill xmlns:a="http://schemas.openxmlformats.org/drawingml/2006/main">
+            <a:srgbClr val="C8A46B"/>
+          </a:solidFill>
+          <a:ln xmlns:a="http://schemas.openxmlformats.org/drawingml/2006/main" w="9525">
+            <a:solidFill>
+              <a:srgbClr val="C8A46B"/>
+            </a:solidFill>
+            <a:prstDash val="solid"/>
+          </a:ln>
+        </p:spPr>
+      </p:sp>
+      <p:sp>
+        <p:nvSpPr>
+          <p:cNvPr id="21" name="">
+            <a:extLst xmlns:a="http://schemas.openxmlformats.org/drawingml/2006/main">
+              <a:ext uri="{FF2B5EF4-FFF2-40B4-BE49-F238E27FC236}">
+                <a16:creationId xmlns:a16="http://schemas.microsoft.com/office/drawing/2014/main" id="{6BE04107-F8C5-474B-8774-65A735569535}"/>
               </a:ext>
             </a:extLst>
           </p:cNvPr>
@@ -7444,7 +7800,7 @@
     </p:spTree>
     <p:extLst>
       <p:ext uri="{BB962C8B-B14F-4D97-AF65-F5344CB8AC3E}">
-        <p14:creationId xmlns:p14="http://schemas.microsoft.com/office/powerpoint/2010/main" val="521288741"/>
+        <p14:creationId xmlns:p14="http://schemas.microsoft.com/office/powerpoint/2010/main" val="844103735"/>
       </p:ext>
     </p:extLst>
   </p:cSld>
@@ -7475,7 +7831,7 @@
           <p:cNvPr id="1" name="">
             <a:extLst xmlns:a="http://schemas.openxmlformats.org/drawingml/2006/main">
               <a:ext uri="{FF2B5EF4-FFF2-40B4-BE49-F238E27FC236}">
-                <a16:creationId xmlns:a16="http://schemas.microsoft.com/office/drawing/2014/main" id="{824DF054-5398-4DBD-8141-3B9FB389B656}"/>
+                <a16:creationId xmlns:a16="http://schemas.microsoft.com/office/drawing/2014/main" id="{1F348423-F1CD-4882-868E-153FC6EC99CC}"/>
               </a:ext>
             </a:extLst>
           </p:cNvPr>
@@ -7531,7 +7887,7 @@
           <p:cNvPr id="2" name="">
             <a:extLst xmlns:a="http://schemas.openxmlformats.org/drawingml/2006/main">
               <a:ext uri="{FF2B5EF4-FFF2-40B4-BE49-F238E27FC236}">
-                <a16:creationId xmlns:a16="http://schemas.microsoft.com/office/drawing/2014/main" id="{97A49988-E431-4D0A-ABE7-C15A8AEB6FC6}"/>
+                <a16:creationId xmlns:a16="http://schemas.microsoft.com/office/drawing/2014/main" id="{EDCDBC94-687C-4045-BE97-DC840250373F}"/>
               </a:ext>
             </a:extLst>
           </p:cNvPr>
@@ -7587,7 +7943,7 @@
           <p:cNvPr id="3" name="">
             <a:extLst xmlns:a="http://schemas.openxmlformats.org/drawingml/2006/main">
               <a:ext uri="{FF2B5EF4-FFF2-40B4-BE49-F238E27FC236}">
-                <a16:creationId xmlns:a16="http://schemas.microsoft.com/office/drawing/2014/main" id="{7CD10A90-A80D-444D-9875-681993CA87D6}"/>
+                <a16:creationId xmlns:a16="http://schemas.microsoft.com/office/drawing/2014/main" id="{FB654A64-2952-416B-B98F-4769FC6D9929}"/>
               </a:ext>
             </a:extLst>
           </p:cNvPr>
@@ -7643,7 +7999,7 @@
           <p:cNvPr id="4" name="">
             <a:extLst xmlns:a="http://schemas.openxmlformats.org/drawingml/2006/main">
               <a:ext uri="{FF2B5EF4-FFF2-40B4-BE49-F238E27FC236}">
-                <a16:creationId xmlns:a16="http://schemas.microsoft.com/office/drawing/2014/main" id="{60A0DA00-FAFF-4EA3-9E76-9648517608D8}"/>
+                <a16:creationId xmlns:a16="http://schemas.microsoft.com/office/drawing/2014/main" id="{FD561D7E-39B0-4780-A3BF-A635C784BED9}"/>
               </a:ext>
             </a:extLst>
           </p:cNvPr>
@@ -7699,7 +8055,7 @@
           <p:cNvPr id="5" name="">
             <a:extLst xmlns:a="http://schemas.openxmlformats.org/drawingml/2006/main">
               <a:ext uri="{FF2B5EF4-FFF2-40B4-BE49-F238E27FC236}">
-                <a16:creationId xmlns:a16="http://schemas.microsoft.com/office/drawing/2014/main" id="{CD964B21-6039-49FC-91F2-760167436626}"/>
+                <a16:creationId xmlns:a16="http://schemas.microsoft.com/office/drawing/2014/main" id="{5F7C1452-3EFD-4C6C-9178-D77CE99AF7DD}"/>
               </a:ext>
             </a:extLst>
           </p:cNvPr>
@@ -7734,7 +8090,7 @@
           <p:cNvPr id="6" name="">
             <a:extLst xmlns:a="http://schemas.openxmlformats.org/drawingml/2006/main">
               <a:ext uri="{FF2B5EF4-FFF2-40B4-BE49-F238E27FC236}">
-                <a16:creationId xmlns:a16="http://schemas.microsoft.com/office/drawing/2014/main" id="{6F6BEF68-4863-44FF-A49A-ED4ECA8AFE22}"/>
+                <a16:creationId xmlns:a16="http://schemas.microsoft.com/office/drawing/2014/main" id="{31E4533D-0AE7-45C9-A78E-3EA55C416E37}"/>
               </a:ext>
             </a:extLst>
           </p:cNvPr>
@@ -7790,7 +8146,7 @@
           <p:cNvPr id="7" name="">
             <a:extLst xmlns:a="http://schemas.openxmlformats.org/drawingml/2006/main">
               <a:ext uri="{FF2B5EF4-FFF2-40B4-BE49-F238E27FC236}">
-                <a16:creationId xmlns:a16="http://schemas.microsoft.com/office/drawing/2014/main" id="{A4FD084F-55C9-4E70-B337-3F7CF1241288}"/>
+                <a16:creationId xmlns:a16="http://schemas.microsoft.com/office/drawing/2014/main" id="{05A00DC5-2213-4499-BB9D-38190103BDCA}"/>
               </a:ext>
             </a:extLst>
           </p:cNvPr>
@@ -7846,7 +8202,7 @@
           <p:cNvPr id="8" name="">
             <a:extLst xmlns:a="http://schemas.openxmlformats.org/drawingml/2006/main">
               <a:ext uri="{FF2B5EF4-FFF2-40B4-BE49-F238E27FC236}">
-                <a16:creationId xmlns:a16="http://schemas.microsoft.com/office/drawing/2014/main" id="{A196C5DB-1B6E-41CE-A355-6BAF3E369D6D}"/>
+                <a16:creationId xmlns:a16="http://schemas.microsoft.com/office/drawing/2014/main" id="{C75A3A95-6FEC-4496-848D-C89D9C5AAFD6}"/>
               </a:ext>
             </a:extLst>
           </p:cNvPr>
@@ -7902,7 +8258,7 @@
           <p:cNvPr id="9" name="">
             <a:extLst xmlns:a="http://schemas.openxmlformats.org/drawingml/2006/main">
               <a:ext uri="{FF2B5EF4-FFF2-40B4-BE49-F238E27FC236}">
-                <a16:creationId xmlns:a16="http://schemas.microsoft.com/office/drawing/2014/main" id="{5497C67F-C540-434F-AB85-E4E734E9F141}"/>
+                <a16:creationId xmlns:a16="http://schemas.microsoft.com/office/drawing/2014/main" id="{61963E4C-4B93-457F-B70D-E994B620A34A}"/>
               </a:ext>
             </a:extLst>
           </p:cNvPr>
@@ -7958,7 +8314,7 @@
           <p:cNvPr id="10" name="">
             <a:extLst xmlns:a="http://schemas.openxmlformats.org/drawingml/2006/main">
               <a:ext uri="{FF2B5EF4-FFF2-40B4-BE49-F238E27FC236}">
-                <a16:creationId xmlns:a16="http://schemas.microsoft.com/office/drawing/2014/main" id="{9B6421C3-97F4-49EC-B7B1-93963146B1D9}"/>
+                <a16:creationId xmlns:a16="http://schemas.microsoft.com/office/drawing/2014/main" id="{7473BE28-CC5B-4493-9EBF-6C341409C552}"/>
               </a:ext>
             </a:extLst>
           </p:cNvPr>
@@ -7991,7 +8347,7 @@
           <p:cNvPr id="11" name="">
             <a:extLst xmlns:a="http://schemas.openxmlformats.org/drawingml/2006/main">
               <a:ext uri="{FF2B5EF4-FFF2-40B4-BE49-F238E27FC236}">
-                <a16:creationId xmlns:a16="http://schemas.microsoft.com/office/drawing/2014/main" id="{A88D65B3-54D3-478A-99A7-2D6165884D37}"/>
+                <a16:creationId xmlns:a16="http://schemas.microsoft.com/office/drawing/2014/main" id="{A25329EC-33F7-4FF0-AC42-F2A2A077A745}"/>
               </a:ext>
             </a:extLst>
           </p:cNvPr>
@@ -8047,7 +8403,7 @@
           <p:cNvPr id="12" name="">
             <a:extLst xmlns:a="http://schemas.openxmlformats.org/drawingml/2006/main">
               <a:ext uri="{FF2B5EF4-FFF2-40B4-BE49-F238E27FC236}">
-                <a16:creationId xmlns:a16="http://schemas.microsoft.com/office/drawing/2014/main" id="{031662B3-80B1-4279-9259-3756488ABF0B}"/>
+                <a16:creationId xmlns:a16="http://schemas.microsoft.com/office/drawing/2014/main" id="{02DEE6BF-5C7D-4E25-8C30-19709ABF153E}"/>
               </a:ext>
             </a:extLst>
           </p:cNvPr>
@@ -8080,7 +8436,7 @@
           <p:cNvPr id="13" name="">
             <a:extLst xmlns:a="http://schemas.openxmlformats.org/drawingml/2006/main">
               <a:ext uri="{FF2B5EF4-FFF2-40B4-BE49-F238E27FC236}">
-                <a16:creationId xmlns:a16="http://schemas.microsoft.com/office/drawing/2014/main" id="{A55A5022-9F4B-421E-A7EA-C7C35B3FCDD3}"/>
+                <a16:creationId xmlns:a16="http://schemas.microsoft.com/office/drawing/2014/main" id="{397D36FC-3B38-49AC-9CCA-978E305BF64F}"/>
               </a:ext>
             </a:extLst>
           </p:cNvPr>
@@ -8136,7 +8492,7 @@
           <p:cNvPr id="14" name="">
             <a:extLst xmlns:a="http://schemas.openxmlformats.org/drawingml/2006/main">
               <a:ext uri="{FF2B5EF4-FFF2-40B4-BE49-F238E27FC236}">
-                <a16:creationId xmlns:a16="http://schemas.microsoft.com/office/drawing/2014/main" id="{BC03A7B6-2A82-4D7E-9A8B-94F12508D74B}"/>
+                <a16:creationId xmlns:a16="http://schemas.microsoft.com/office/drawing/2014/main" id="{0BE0AAFD-1869-496C-9977-5A28DF9F3018}"/>
               </a:ext>
             </a:extLst>
           </p:cNvPr>
@@ -8169,7 +8525,7 @@
           <p:cNvPr id="15" name="">
             <a:extLst xmlns:a="http://schemas.openxmlformats.org/drawingml/2006/main">
               <a:ext uri="{FF2B5EF4-FFF2-40B4-BE49-F238E27FC236}">
-                <a16:creationId xmlns:a16="http://schemas.microsoft.com/office/drawing/2014/main" id="{EFD99ABF-4610-4C5F-82CA-CC9AFC48CDDF}"/>
+                <a16:creationId xmlns:a16="http://schemas.microsoft.com/office/drawing/2014/main" id="{D41DA221-3736-4F7A-A55F-2BB4CB94AE30}"/>
               </a:ext>
             </a:extLst>
           </p:cNvPr>
@@ -8225,7 +8581,7 @@
           <p:cNvPr id="16" name="">
             <a:extLst xmlns:a="http://schemas.openxmlformats.org/drawingml/2006/main">
               <a:ext uri="{FF2B5EF4-FFF2-40B4-BE49-F238E27FC236}">
-                <a16:creationId xmlns:a16="http://schemas.microsoft.com/office/drawing/2014/main" id="{53491DFC-AF46-47C3-89E2-AAF901664A7A}"/>
+                <a16:creationId xmlns:a16="http://schemas.microsoft.com/office/drawing/2014/main" id="{7700444D-A3D3-42BD-B79D-91AEB2E11A98}"/>
               </a:ext>
             </a:extLst>
           </p:cNvPr>
@@ -8258,7 +8614,7 @@
           <p:cNvPr id="17" name="">
             <a:extLst xmlns:a="http://schemas.openxmlformats.org/drawingml/2006/main">
               <a:ext uri="{FF2B5EF4-FFF2-40B4-BE49-F238E27FC236}">
-                <a16:creationId xmlns:a16="http://schemas.microsoft.com/office/drawing/2014/main" id="{6573AC32-0A11-49E7-B7F5-1F94FB713353}"/>
+                <a16:creationId xmlns:a16="http://schemas.microsoft.com/office/drawing/2014/main" id="{2316B147-3C99-4D17-8CD7-85C0E5C66AAE}"/>
               </a:ext>
             </a:extLst>
           </p:cNvPr>
@@ -8314,7 +8670,7 @@
           <p:cNvPr id="18" name="">
             <a:extLst xmlns:a="http://schemas.openxmlformats.org/drawingml/2006/main">
               <a:ext uri="{FF2B5EF4-FFF2-40B4-BE49-F238E27FC236}">
-                <a16:creationId xmlns:a16="http://schemas.microsoft.com/office/drawing/2014/main" id="{63C1DA9A-626F-46C8-8062-3F798BDC583F}"/>
+                <a16:creationId xmlns:a16="http://schemas.microsoft.com/office/drawing/2014/main" id="{F820A6E2-CF32-4B69-942C-2EE514287373}"/>
               </a:ext>
             </a:extLst>
           </p:cNvPr>
@@ -8347,7 +8703,7 @@
           <p:cNvPr id="19" name="">
             <a:extLst xmlns:a="http://schemas.openxmlformats.org/drawingml/2006/main">
               <a:ext uri="{FF2B5EF4-FFF2-40B4-BE49-F238E27FC236}">
-                <a16:creationId xmlns:a16="http://schemas.microsoft.com/office/drawing/2014/main" id="{4091BE15-DDE8-4D20-87F4-57E7D9CD4C5E}"/>
+                <a16:creationId xmlns:a16="http://schemas.microsoft.com/office/drawing/2014/main" id="{0EB489FC-1904-4435-B143-23E86280749C}"/>
               </a:ext>
             </a:extLst>
           </p:cNvPr>
@@ -8401,7 +8757,7 @@
     </p:spTree>
     <p:extLst>
       <p:ext uri="{BB962C8B-B14F-4D97-AF65-F5344CB8AC3E}">
-        <p14:creationId xmlns:p14="http://schemas.microsoft.com/office/powerpoint/2010/main" val="653320340"/>
+        <p14:creationId xmlns:p14="http://schemas.microsoft.com/office/powerpoint/2010/main" val="1536764218"/>
       </p:ext>
     </p:extLst>
   </p:cSld>
@@ -8432,7 +8788,7 @@
           <p:cNvPr id="1" name="">
             <a:extLst xmlns:a="http://schemas.openxmlformats.org/drawingml/2006/main">
               <a:ext uri="{FF2B5EF4-FFF2-40B4-BE49-F238E27FC236}">
-                <a16:creationId xmlns:a16="http://schemas.microsoft.com/office/drawing/2014/main" id="{8E43E82B-8B6C-446B-9BDA-C783E8024AFB}"/>
+                <a16:creationId xmlns:a16="http://schemas.microsoft.com/office/drawing/2014/main" id="{BFC6A4A2-642A-48CB-B13F-AC4CFE62DC77}"/>
               </a:ext>
             </a:extLst>
           </p:cNvPr>
@@ -8488,7 +8844,7 @@
           <p:cNvPr id="2" name="">
             <a:extLst xmlns:a="http://schemas.openxmlformats.org/drawingml/2006/main">
               <a:ext uri="{FF2B5EF4-FFF2-40B4-BE49-F238E27FC236}">
-                <a16:creationId xmlns:a16="http://schemas.microsoft.com/office/drawing/2014/main" id="{CE102740-3CA3-428C-AACD-2802C1B669F0}"/>
+                <a16:creationId xmlns:a16="http://schemas.microsoft.com/office/drawing/2014/main" id="{9D6BD279-3DFC-4CE1-BAD4-97211DF7878F}"/>
               </a:ext>
             </a:extLst>
           </p:cNvPr>
@@ -8544,7 +8900,7 @@
           <p:cNvPr id="3" name="">
             <a:extLst xmlns:a="http://schemas.openxmlformats.org/drawingml/2006/main">
               <a:ext uri="{FF2B5EF4-FFF2-40B4-BE49-F238E27FC236}">
-                <a16:creationId xmlns:a16="http://schemas.microsoft.com/office/drawing/2014/main" id="{3F64AB0C-6BA9-43DC-B116-70F0D6E0AC15}"/>
+                <a16:creationId xmlns:a16="http://schemas.microsoft.com/office/drawing/2014/main" id="{274B3318-CD5F-4900-A814-211B55D19FED}"/>
               </a:ext>
             </a:extLst>
           </p:cNvPr>
@@ -8600,7 +8956,7 @@
           <p:cNvPr id="4" name="">
             <a:extLst xmlns:a="http://schemas.openxmlformats.org/drawingml/2006/main">
               <a:ext uri="{FF2B5EF4-FFF2-40B4-BE49-F238E27FC236}">
-                <a16:creationId xmlns:a16="http://schemas.microsoft.com/office/drawing/2014/main" id="{ACEB5F8D-F3C7-4A55-9F9D-48C8B3FCD9A7}"/>
+                <a16:creationId xmlns:a16="http://schemas.microsoft.com/office/drawing/2014/main" id="{85B7BF08-CD8E-46EE-B2CE-A72B44C566A9}"/>
               </a:ext>
             </a:extLst>
           </p:cNvPr>
@@ -8656,7 +9012,7 @@
           <p:cNvPr id="5" name="">
             <a:extLst xmlns:a="http://schemas.openxmlformats.org/drawingml/2006/main">
               <a:ext uri="{FF2B5EF4-FFF2-40B4-BE49-F238E27FC236}">
-                <a16:creationId xmlns:a16="http://schemas.microsoft.com/office/drawing/2014/main" id="{32477DC1-59BC-454F-BE63-069909BB0C4C}"/>
+                <a16:creationId xmlns:a16="http://schemas.microsoft.com/office/drawing/2014/main" id="{E16F5F6B-C133-4A8B-8019-CC0CB0E63E03}"/>
               </a:ext>
             </a:extLst>
           </p:cNvPr>
@@ -8691,7 +9047,7 @@
           <p:cNvPr id="6" name="">
             <a:extLst xmlns:a="http://schemas.openxmlformats.org/drawingml/2006/main">
               <a:ext uri="{FF2B5EF4-FFF2-40B4-BE49-F238E27FC236}">
-                <a16:creationId xmlns:a16="http://schemas.microsoft.com/office/drawing/2014/main" id="{3026B190-5671-4E4A-BF72-0F5A86960607}"/>
+                <a16:creationId xmlns:a16="http://schemas.microsoft.com/office/drawing/2014/main" id="{AD5213A6-5922-42A7-A323-1E99C28D6AA8}"/>
               </a:ext>
             </a:extLst>
           </p:cNvPr>
@@ -8747,7 +9103,7 @@
           <p:cNvPr id="7" name="">
             <a:extLst xmlns:a="http://schemas.openxmlformats.org/drawingml/2006/main">
               <a:ext uri="{FF2B5EF4-FFF2-40B4-BE49-F238E27FC236}">
-                <a16:creationId xmlns:a16="http://schemas.microsoft.com/office/drawing/2014/main" id="{C110CD32-D4F8-4015-ADF3-BAF96B14CE8B}"/>
+                <a16:creationId xmlns:a16="http://schemas.microsoft.com/office/drawing/2014/main" id="{6325AB1C-8821-49B1-9BB3-024DC55DCFF8}"/>
               </a:ext>
             </a:extLst>
           </p:cNvPr>
@@ -8803,7 +9159,7 @@
           <p:cNvPr id="8" name="">
             <a:extLst xmlns:a="http://schemas.openxmlformats.org/drawingml/2006/main">
               <a:ext uri="{FF2B5EF4-FFF2-40B4-BE49-F238E27FC236}">
-                <a16:creationId xmlns:a16="http://schemas.microsoft.com/office/drawing/2014/main" id="{ADD2C4E1-E1CC-4F33-B89A-36E205182DB9}"/>
+                <a16:creationId xmlns:a16="http://schemas.microsoft.com/office/drawing/2014/main" id="{60748FE1-C56B-4EC8-9F93-4699975917F3}"/>
               </a:ext>
             </a:extLst>
           </p:cNvPr>
@@ -8859,7 +9215,7 @@
           <p:cNvPr id="9" name="">
             <a:extLst xmlns:a="http://schemas.openxmlformats.org/drawingml/2006/main">
               <a:ext uri="{FF2B5EF4-FFF2-40B4-BE49-F238E27FC236}">
-                <a16:creationId xmlns:a16="http://schemas.microsoft.com/office/drawing/2014/main" id="{2F515BCC-41C5-401C-9158-597BBCC093A4}"/>
+                <a16:creationId xmlns:a16="http://schemas.microsoft.com/office/drawing/2014/main" id="{60225E58-AA56-4A40-95AC-46BC16D0FC2A}"/>
               </a:ext>
             </a:extLst>
           </p:cNvPr>
@@ -8915,7 +9271,7 @@
           <p:cNvPr id="10" name="">
             <a:extLst xmlns:a="http://schemas.openxmlformats.org/drawingml/2006/main">
               <a:ext uri="{FF2B5EF4-FFF2-40B4-BE49-F238E27FC236}">
-                <a16:creationId xmlns:a16="http://schemas.microsoft.com/office/drawing/2014/main" id="{5582DD5C-1319-4060-8C59-F065AA476C16}"/>
+                <a16:creationId xmlns:a16="http://schemas.microsoft.com/office/drawing/2014/main" id="{DE4EEE55-3F00-4068-9386-B3F91C678C19}"/>
               </a:ext>
             </a:extLst>
           </p:cNvPr>
@@ -8948,7 +9304,7 @@
           <p:cNvPr id="11" name="">
             <a:extLst xmlns:a="http://schemas.openxmlformats.org/drawingml/2006/main">
               <a:ext uri="{FF2B5EF4-FFF2-40B4-BE49-F238E27FC236}">
-                <a16:creationId xmlns:a16="http://schemas.microsoft.com/office/drawing/2014/main" id="{0E70E65B-2D5A-4984-8166-AF8D6854F285}"/>
+                <a16:creationId xmlns:a16="http://schemas.microsoft.com/office/drawing/2014/main" id="{6CD0C1E5-8EA7-48C1-B6C4-F7886EF1BC9D}"/>
               </a:ext>
             </a:extLst>
           </p:cNvPr>
@@ -9004,7 +9360,7 @@
           <p:cNvPr id="12" name="">
             <a:extLst xmlns:a="http://schemas.openxmlformats.org/drawingml/2006/main">
               <a:ext uri="{FF2B5EF4-FFF2-40B4-BE49-F238E27FC236}">
-                <a16:creationId xmlns:a16="http://schemas.microsoft.com/office/drawing/2014/main" id="{2201A4F6-42D9-4D1B-900C-77157CB4AEA7}"/>
+                <a16:creationId xmlns:a16="http://schemas.microsoft.com/office/drawing/2014/main" id="{911A4DC3-AC73-4F4D-842A-E3A3BC55BB4F}"/>
               </a:ext>
             </a:extLst>
           </p:cNvPr>
@@ -9037,7 +9393,7 @@
           <p:cNvPr id="13" name="">
             <a:extLst xmlns:a="http://schemas.openxmlformats.org/drawingml/2006/main">
               <a:ext uri="{FF2B5EF4-FFF2-40B4-BE49-F238E27FC236}">
-                <a16:creationId xmlns:a16="http://schemas.microsoft.com/office/drawing/2014/main" id="{3A675A63-F2C4-4E7C-A557-A235A9D0314E}"/>
+                <a16:creationId xmlns:a16="http://schemas.microsoft.com/office/drawing/2014/main" id="{B53AA0AE-A746-48E3-923E-2D31330A61E8}"/>
               </a:ext>
             </a:extLst>
           </p:cNvPr>
@@ -9091,7 +9447,7 @@
     </p:spTree>
     <p:extLst>
       <p:ext uri="{BB962C8B-B14F-4D97-AF65-F5344CB8AC3E}">
-        <p14:creationId xmlns:p14="http://schemas.microsoft.com/office/powerpoint/2010/main" val="1559738057"/>
+        <p14:creationId xmlns:p14="http://schemas.microsoft.com/office/powerpoint/2010/main" val="2115244846"/>
       </p:ext>
     </p:extLst>
   </p:cSld>
@@ -9122,7 +9478,7 @@
           <p:cNvPr id="1" name="">
             <a:extLst xmlns:a="http://schemas.openxmlformats.org/drawingml/2006/main">
               <a:ext uri="{FF2B5EF4-FFF2-40B4-BE49-F238E27FC236}">
-                <a16:creationId xmlns:a16="http://schemas.microsoft.com/office/drawing/2014/main" id="{B25DEADC-B241-4D25-899A-E7F227AE543A}"/>
+                <a16:creationId xmlns:a16="http://schemas.microsoft.com/office/drawing/2014/main" id="{EDC94712-A29D-455E-AEE4-5DC9A0EB8B12}"/>
               </a:ext>
             </a:extLst>
           </p:cNvPr>
@@ -9178,7 +9534,7 @@
           <p:cNvPr id="2" name="">
             <a:extLst xmlns:a="http://schemas.openxmlformats.org/drawingml/2006/main">
               <a:ext uri="{FF2B5EF4-FFF2-40B4-BE49-F238E27FC236}">
-                <a16:creationId xmlns:a16="http://schemas.microsoft.com/office/drawing/2014/main" id="{7B2CC50C-F797-485C-9BCD-13AADE84CE5D}"/>
+                <a16:creationId xmlns:a16="http://schemas.microsoft.com/office/drawing/2014/main" id="{87B8FCEB-60B9-4473-97D2-D37B392244AF}"/>
               </a:ext>
             </a:extLst>
           </p:cNvPr>
@@ -9234,7 +9590,7 @@
           <p:cNvPr id="3" name="">
             <a:extLst xmlns:a="http://schemas.openxmlformats.org/drawingml/2006/main">
               <a:ext uri="{FF2B5EF4-FFF2-40B4-BE49-F238E27FC236}">
-                <a16:creationId xmlns:a16="http://schemas.microsoft.com/office/drawing/2014/main" id="{FBF6BB80-2655-4F60-BD1A-1EA3A8CDAA7C}"/>
+                <a16:creationId xmlns:a16="http://schemas.microsoft.com/office/drawing/2014/main" id="{2393D558-7BE6-4E9A-AD45-3328E1DCCAA7}"/>
               </a:ext>
             </a:extLst>
           </p:cNvPr>
@@ -9290,7 +9646,7 @@
           <p:cNvPr id="4" name="">
             <a:extLst xmlns:a="http://schemas.openxmlformats.org/drawingml/2006/main">
               <a:ext uri="{FF2B5EF4-FFF2-40B4-BE49-F238E27FC236}">
-                <a16:creationId xmlns:a16="http://schemas.microsoft.com/office/drawing/2014/main" id="{460E8D36-3AD8-463B-865E-5D3A33FB2659}"/>
+                <a16:creationId xmlns:a16="http://schemas.microsoft.com/office/drawing/2014/main" id="{45A7A64A-68FE-4A1E-AD18-9514EAC00C1F}"/>
               </a:ext>
             </a:extLst>
           </p:cNvPr>
@@ -9346,7 +9702,7 @@
           <p:cNvPr id="5" name="">
             <a:extLst xmlns:a="http://schemas.openxmlformats.org/drawingml/2006/main">
               <a:ext uri="{FF2B5EF4-FFF2-40B4-BE49-F238E27FC236}">
-                <a16:creationId xmlns:a16="http://schemas.microsoft.com/office/drawing/2014/main" id="{A0E813DE-FBA7-4902-BB0C-0D30CC7A325D}"/>
+                <a16:creationId xmlns:a16="http://schemas.microsoft.com/office/drawing/2014/main" id="{A80C1BFB-4AA0-4AA7-A6AD-3D816EAA95B6}"/>
               </a:ext>
             </a:extLst>
           </p:cNvPr>
@@ -9381,7 +9737,7 @@
           <p:cNvPr id="6" name="">
             <a:extLst xmlns:a="http://schemas.openxmlformats.org/drawingml/2006/main">
               <a:ext uri="{FF2B5EF4-FFF2-40B4-BE49-F238E27FC236}">
-                <a16:creationId xmlns:a16="http://schemas.microsoft.com/office/drawing/2014/main" id="{AF624DA1-8DB0-4536-A5F6-D2F85875B870}"/>
+                <a16:creationId xmlns:a16="http://schemas.microsoft.com/office/drawing/2014/main" id="{510F9033-86A7-4F18-88CB-B378BD93A8F6}"/>
               </a:ext>
             </a:extLst>
           </p:cNvPr>
@@ -9437,7 +9793,7 @@
           <p:cNvPr id="7" name="">
             <a:extLst xmlns:a="http://schemas.openxmlformats.org/drawingml/2006/main">
               <a:ext uri="{FF2B5EF4-FFF2-40B4-BE49-F238E27FC236}">
-                <a16:creationId xmlns:a16="http://schemas.microsoft.com/office/drawing/2014/main" id="{6FE849EE-5CC1-4635-845D-839005078D30}"/>
+                <a16:creationId xmlns:a16="http://schemas.microsoft.com/office/drawing/2014/main" id="{47B86FE6-F6B0-4819-A4A9-F593D4F17352}"/>
               </a:ext>
             </a:extLst>
           </p:cNvPr>
@@ -9493,7 +9849,7 @@
           <p:cNvPr id="8" name="">
             <a:extLst xmlns:a="http://schemas.openxmlformats.org/drawingml/2006/main">
               <a:ext uri="{FF2B5EF4-FFF2-40B4-BE49-F238E27FC236}">
-                <a16:creationId xmlns:a16="http://schemas.microsoft.com/office/drawing/2014/main" id="{B4853380-215A-4779-B367-3C8C98C1B003}"/>
+                <a16:creationId xmlns:a16="http://schemas.microsoft.com/office/drawing/2014/main" id="{C9B338E2-14B5-475C-AC8D-2D2B1070E437}"/>
               </a:ext>
             </a:extLst>
           </p:cNvPr>
@@ -9549,7 +9905,7 @@
           <p:cNvPr id="9" name="">
             <a:extLst xmlns:a="http://schemas.openxmlformats.org/drawingml/2006/main">
               <a:ext uri="{FF2B5EF4-FFF2-40B4-BE49-F238E27FC236}">
-                <a16:creationId xmlns:a16="http://schemas.microsoft.com/office/drawing/2014/main" id="{30CD8A81-DAA1-4719-8E5E-9E64A23492CE}"/>
+                <a16:creationId xmlns:a16="http://schemas.microsoft.com/office/drawing/2014/main" id="{EF63B2C3-3EF7-47BA-A78B-0AB86F399C76}"/>
               </a:ext>
             </a:extLst>
           </p:cNvPr>
@@ -9605,7 +9961,7 @@
           <p:cNvPr id="10" name="">
             <a:extLst xmlns:a="http://schemas.openxmlformats.org/drawingml/2006/main">
               <a:ext uri="{FF2B5EF4-FFF2-40B4-BE49-F238E27FC236}">
-                <a16:creationId xmlns:a16="http://schemas.microsoft.com/office/drawing/2014/main" id="{BF9EE704-1477-4CC6-A1D0-3B72E05680BB}"/>
+                <a16:creationId xmlns:a16="http://schemas.microsoft.com/office/drawing/2014/main" id="{26473091-D29A-4C60-B655-7B21E3955AB0}"/>
               </a:ext>
             </a:extLst>
           </p:cNvPr>
@@ -9638,7 +9994,7 @@
           <p:cNvPr id="11" name="">
             <a:extLst xmlns:a="http://schemas.openxmlformats.org/drawingml/2006/main">
               <a:ext uri="{FF2B5EF4-FFF2-40B4-BE49-F238E27FC236}">
-                <a16:creationId xmlns:a16="http://schemas.microsoft.com/office/drawing/2014/main" id="{0E15A35C-477D-4787-9408-99D77F4010E2}"/>
+                <a16:creationId xmlns:a16="http://schemas.microsoft.com/office/drawing/2014/main" id="{0017036A-6F08-4351-9A26-FDC857B46EF8}"/>
               </a:ext>
             </a:extLst>
           </p:cNvPr>
@@ -9694,7 +10050,7 @@
           <p:cNvPr id="12" name="">
             <a:extLst xmlns:a="http://schemas.openxmlformats.org/drawingml/2006/main">
               <a:ext uri="{FF2B5EF4-FFF2-40B4-BE49-F238E27FC236}">
-                <a16:creationId xmlns:a16="http://schemas.microsoft.com/office/drawing/2014/main" id="{854D0C52-4432-4653-9A34-577C685D7F6F}"/>
+                <a16:creationId xmlns:a16="http://schemas.microsoft.com/office/drawing/2014/main" id="{C6C670B5-BC0C-4BBF-ABDE-398AB41E4923}"/>
               </a:ext>
             </a:extLst>
           </p:cNvPr>
@@ -9727,7 +10083,7 @@
           <p:cNvPr id="13" name="">
             <a:extLst xmlns:a="http://schemas.openxmlformats.org/drawingml/2006/main">
               <a:ext uri="{FF2B5EF4-FFF2-40B4-BE49-F238E27FC236}">
-                <a16:creationId xmlns:a16="http://schemas.microsoft.com/office/drawing/2014/main" id="{CAAD23EF-BBCB-4202-8EC1-10CB0D6B0180}"/>
+                <a16:creationId xmlns:a16="http://schemas.microsoft.com/office/drawing/2014/main" id="{71670125-0FDC-417B-9B61-744DB263F2C1}"/>
               </a:ext>
             </a:extLst>
           </p:cNvPr>
@@ -9783,7 +10139,7 @@
           <p:cNvPr id="14" name="">
             <a:extLst xmlns:a="http://schemas.openxmlformats.org/drawingml/2006/main">
               <a:ext uri="{FF2B5EF4-FFF2-40B4-BE49-F238E27FC236}">
-                <a16:creationId xmlns:a16="http://schemas.microsoft.com/office/drawing/2014/main" id="{AA428B24-D1D4-46B7-80A0-D31B5FCF46C4}"/>
+                <a16:creationId xmlns:a16="http://schemas.microsoft.com/office/drawing/2014/main" id="{BC79E477-0651-4D15-89BF-0485451DB8D6}"/>
               </a:ext>
             </a:extLst>
           </p:cNvPr>
@@ -9816,7 +10172,7 @@
           <p:cNvPr id="15" name="">
             <a:extLst xmlns:a="http://schemas.openxmlformats.org/drawingml/2006/main">
               <a:ext uri="{FF2B5EF4-FFF2-40B4-BE49-F238E27FC236}">
-                <a16:creationId xmlns:a16="http://schemas.microsoft.com/office/drawing/2014/main" id="{10854A20-724E-4F8F-9E67-FCAE2BBC53F8}"/>
+                <a16:creationId xmlns:a16="http://schemas.microsoft.com/office/drawing/2014/main" id="{0841E3EC-269F-4AFB-9B03-3A9FC45F4F8C}"/>
               </a:ext>
             </a:extLst>
           </p:cNvPr>
@@ -9872,7 +10228,7 @@
           <p:cNvPr id="16" name="">
             <a:extLst xmlns:a="http://schemas.openxmlformats.org/drawingml/2006/main">
               <a:ext uri="{FF2B5EF4-FFF2-40B4-BE49-F238E27FC236}">
-                <a16:creationId xmlns:a16="http://schemas.microsoft.com/office/drawing/2014/main" id="{54F70B6B-43F6-4353-85F8-F20FC83F341B}"/>
+                <a16:creationId xmlns:a16="http://schemas.microsoft.com/office/drawing/2014/main" id="{2071DD62-6BEC-4BEC-9A68-4A692205A5C7}"/>
               </a:ext>
             </a:extLst>
           </p:cNvPr>
@@ -9905,7 +10261,7 @@
           <p:cNvPr id="17" name="">
             <a:extLst xmlns:a="http://schemas.openxmlformats.org/drawingml/2006/main">
               <a:ext uri="{FF2B5EF4-FFF2-40B4-BE49-F238E27FC236}">
-                <a16:creationId xmlns:a16="http://schemas.microsoft.com/office/drawing/2014/main" id="{1105028F-BC21-45CD-8449-41AE0D0C6C7F}"/>
+                <a16:creationId xmlns:a16="http://schemas.microsoft.com/office/drawing/2014/main" id="{14C57527-01A7-4231-A2A2-39C3F481D849}"/>
               </a:ext>
             </a:extLst>
           </p:cNvPr>
@@ -9961,7 +10317,7 @@
           <p:cNvPr id="18" name="">
             <a:extLst xmlns:a="http://schemas.openxmlformats.org/drawingml/2006/main">
               <a:ext uri="{FF2B5EF4-FFF2-40B4-BE49-F238E27FC236}">
-                <a16:creationId xmlns:a16="http://schemas.microsoft.com/office/drawing/2014/main" id="{ACA2B3AB-7BA7-4876-8B35-517AEA231493}"/>
+                <a16:creationId xmlns:a16="http://schemas.microsoft.com/office/drawing/2014/main" id="{9896EB70-F02C-41B7-B6D3-51E783DE6AA1}"/>
               </a:ext>
             </a:extLst>
           </p:cNvPr>
@@ -9994,7 +10350,7 @@
           <p:cNvPr id="19" name="">
             <a:extLst xmlns:a="http://schemas.openxmlformats.org/drawingml/2006/main">
               <a:ext uri="{FF2B5EF4-FFF2-40B4-BE49-F238E27FC236}">
-                <a16:creationId xmlns:a16="http://schemas.microsoft.com/office/drawing/2014/main" id="{22A7D3BC-1021-4005-8777-8B034A4A6DE9}"/>
+                <a16:creationId xmlns:a16="http://schemas.microsoft.com/office/drawing/2014/main" id="{BF8296D0-D5AF-4969-AFB6-79668E5B60B1}"/>
               </a:ext>
             </a:extLst>
           </p:cNvPr>
@@ -10048,7 +10404,7 @@
     </p:spTree>
     <p:extLst>
       <p:ext uri="{BB962C8B-B14F-4D97-AF65-F5344CB8AC3E}">
-        <p14:creationId xmlns:p14="http://schemas.microsoft.com/office/powerpoint/2010/main" val="2089293836"/>
+        <p14:creationId xmlns:p14="http://schemas.microsoft.com/office/powerpoint/2010/main" val="713933341"/>
       </p:ext>
     </p:extLst>
   </p:cSld>

</xml_diff>